<commit_message>
elasticsearch 실습 자료 추가 및 kubernates 자료 보강
- .env 시크릿 파일 추적 해제, IDE/임시 파일 gitignore 규칙 보강
- elasticsearch back 프로젝트, ppt 자료 추가
- kubernates yaml 실습 자료 보강 및 ppt 업데이트
</commit_message>
<xml_diff>
--- a/ppt/K-Training Kafka.pptx
+++ b/ppt/K-Training Kafka.pptx
@@ -10,6 +10,9 @@
     <p:sldId id="259" r:id="rId4"/>
     <p:sldId id="260" r:id="rId5"/>
     <p:sldId id="258" r:id="rId6"/>
+    <p:sldId id="261" r:id="rId7"/>
+    <p:sldId id="262" r:id="rId8"/>
+    <p:sldId id="263" r:id="rId9"/>
   </p:sldIdLst>
   <p:sldSz cx="12192000" cy="6858000"/>
   <p:notesSz cx="6858000" cy="9144000"/>
@@ -108,6 +111,32 @@
       </a:defRPr>
     </a:lvl9pPr>
   </p:defaultTextStyle>
+  <p:extLst>
+    <p:ext uri="{521415D9-36F7-43E2-AB2F-B90AF26B5E84}">
+      <p14:sectionLst xmlns:p14="http://schemas.microsoft.com/office/powerpoint/2010/main">
+        <p14:section name="기본 구역" id="{586BCD52-3BF1-4B68-8DF2-349C0350BBC2}">
+          <p14:sldIdLst>
+            <p14:sldId id="256"/>
+          </p14:sldIdLst>
+        </p14:section>
+        <p14:section name="1강" id="{9DBB78F9-9FB4-43FD-A570-54B6DD443057}">
+          <p14:sldIdLst>
+            <p14:sldId id="257"/>
+            <p14:sldId id="259"/>
+            <p14:sldId id="260"/>
+          </p14:sldIdLst>
+        </p14:section>
+        <p14:section name="2강" id="{E5C016FB-5A95-4D2B-81C2-A863D45419A0}">
+          <p14:sldIdLst>
+            <p14:sldId id="258"/>
+            <p14:sldId id="261"/>
+            <p14:sldId id="262"/>
+            <p14:sldId id="263"/>
+          </p14:sldIdLst>
+        </p14:section>
+      </p14:sectionLst>
+    </p:ext>
+  </p:extLst>
 </p:presentation>
 </file>
 
@@ -5994,14 +6023,3082 @@
           <a:bodyPr/>
           <a:lstStyle/>
           <a:p>
-            <a:endParaRPr lang="ko-KR" altLang="en-US"/>
+            <a:r>
+              <a:rPr lang="en-US" altLang="ko-KR"/>
+              <a:t>2</a:t>
+            </a:r>
+            <a:r>
+              <a:rPr lang="ko-KR" altLang="en-US"/>
+              <a:t>강 </a:t>
+            </a:r>
+            <a:r>
+              <a:rPr lang="en-US" altLang="ko-KR"/>
+              <a:t>IDE Docker </a:t>
+            </a:r>
+            <a:r>
+              <a:rPr lang="ko-KR" altLang="en-US"/>
+              <a:t>개발환경 셋팅</a:t>
+            </a:r>
+          </a:p>
+        </p:txBody>
+      </p:sp>
+      <p:grpSp>
+        <p:nvGrpSpPr>
+          <p:cNvPr id="7" name="그룹 6">
+            <a:extLst>
+              <a:ext uri="{FF2B5EF4-FFF2-40B4-BE49-F238E27FC236}">
+                <a16:creationId xmlns:a16="http://schemas.microsoft.com/office/drawing/2014/main" id="{E508080C-135E-D493-8DC7-01CE8ACA70EA}"/>
+              </a:ext>
+            </a:extLst>
+          </p:cNvPr>
+          <p:cNvGrpSpPr/>
+          <p:nvPr/>
+        </p:nvGrpSpPr>
+        <p:grpSpPr>
+          <a:xfrm>
+            <a:off x="459876" y="1875618"/>
+            <a:ext cx="5458587" cy="562053"/>
+            <a:chOff x="1258773" y="1798615"/>
+            <a:chExt cx="5458587" cy="562053"/>
+          </a:xfrm>
+        </p:grpSpPr>
+        <p:pic>
+          <p:nvPicPr>
+            <p:cNvPr id="4" name="그림 3">
+              <a:extLst>
+                <a:ext uri="{FF2B5EF4-FFF2-40B4-BE49-F238E27FC236}">
+                  <a16:creationId xmlns:a16="http://schemas.microsoft.com/office/drawing/2014/main" id="{63D88A0E-D2F7-1384-EC34-FD40C9CEE0AC}"/>
+                </a:ext>
+              </a:extLst>
+            </p:cNvPr>
+            <p:cNvPicPr>
+              <a:picLocks noChangeAspect="1"/>
+            </p:cNvPicPr>
+            <p:nvPr/>
+          </p:nvPicPr>
+          <p:blipFill>
+            <a:blip r:embed="rId2"/>
+            <a:stretch>
+              <a:fillRect/>
+            </a:stretch>
+          </p:blipFill>
+          <p:spPr>
+            <a:xfrm>
+              <a:off x="1258773" y="2122510"/>
+              <a:ext cx="5458587" cy="238158"/>
+            </a:xfrm>
+            <a:prstGeom prst="rect">
+              <a:avLst/>
+            </a:prstGeom>
+          </p:spPr>
+        </p:pic>
+        <p:pic>
+          <p:nvPicPr>
+            <p:cNvPr id="6" name="그림 5">
+              <a:extLst>
+                <a:ext uri="{FF2B5EF4-FFF2-40B4-BE49-F238E27FC236}">
+                  <a16:creationId xmlns:a16="http://schemas.microsoft.com/office/drawing/2014/main" id="{8F703EB1-8610-4B29-A7E5-C1535F6FE6FF}"/>
+                </a:ext>
+              </a:extLst>
+            </p:cNvPr>
+            <p:cNvPicPr>
+              <a:picLocks noChangeAspect="1"/>
+            </p:cNvPicPr>
+            <p:nvPr/>
+          </p:nvPicPr>
+          <p:blipFill>
+            <a:blip r:embed="rId3"/>
+            <a:stretch>
+              <a:fillRect/>
+            </a:stretch>
+          </p:blipFill>
+          <p:spPr>
+            <a:xfrm>
+              <a:off x="1258773" y="1798615"/>
+              <a:ext cx="1390844" cy="323895"/>
+            </a:xfrm>
+            <a:prstGeom prst="rect">
+              <a:avLst/>
+            </a:prstGeom>
+          </p:spPr>
+        </p:pic>
+      </p:grpSp>
+      <p:sp>
+        <p:nvSpPr>
+          <p:cNvPr id="8" name="TextBox 7">
+            <a:extLst>
+              <a:ext uri="{FF2B5EF4-FFF2-40B4-BE49-F238E27FC236}">
+                <a16:creationId xmlns:a16="http://schemas.microsoft.com/office/drawing/2014/main" id="{B5603031-5503-7B5E-FC25-2F39649E8271}"/>
+              </a:ext>
+            </a:extLst>
+          </p:cNvPr>
+          <p:cNvSpPr txBox="1"/>
+          <p:nvPr/>
+        </p:nvSpPr>
+        <p:spPr>
+          <a:xfrm>
+            <a:off x="459876" y="2498367"/>
+            <a:ext cx="3137836" cy="261610"/>
+          </a:xfrm>
+          <a:prstGeom prst="rect">
+            <a:avLst/>
+          </a:prstGeom>
+          <a:noFill/>
+        </p:spPr>
+        <p:txBody>
+          <a:bodyPr wrap="square" rtlCol="0">
+            <a:spAutoFit/>
+          </a:bodyPr>
+          <a:lstStyle/>
+          <a:p>
+            <a:r>
+              <a:rPr lang="ko-KR" altLang="en-US" sz="1100"/>
+              <a:t>의존성 추가</a:t>
+            </a:r>
+          </a:p>
+        </p:txBody>
+      </p:sp>
+      <p:pic>
+        <p:nvPicPr>
+          <p:cNvPr id="19" name="그림 18">
+            <a:extLst>
+              <a:ext uri="{FF2B5EF4-FFF2-40B4-BE49-F238E27FC236}">
+                <a16:creationId xmlns:a16="http://schemas.microsoft.com/office/drawing/2014/main" id="{8C28672C-0F09-0DFB-B256-5F33B617FD82}"/>
+              </a:ext>
+            </a:extLst>
+          </p:cNvPr>
+          <p:cNvPicPr>
+            <a:picLocks noChangeAspect="1"/>
+          </p:cNvPicPr>
+          <p:nvPr/>
+        </p:nvPicPr>
+        <p:blipFill>
+          <a:blip r:embed="rId4"/>
+          <a:stretch>
+            <a:fillRect/>
+          </a:stretch>
+        </p:blipFill>
+        <p:spPr>
+          <a:xfrm>
+            <a:off x="459876" y="2820673"/>
+            <a:ext cx="3648584" cy="1533739"/>
+          </a:xfrm>
+          <a:prstGeom prst="rect">
+            <a:avLst/>
+          </a:prstGeom>
+        </p:spPr>
+      </p:pic>
+      <p:pic>
+        <p:nvPicPr>
+          <p:cNvPr id="21" name="그림 20">
+            <a:extLst>
+              <a:ext uri="{FF2B5EF4-FFF2-40B4-BE49-F238E27FC236}">
+                <a16:creationId xmlns:a16="http://schemas.microsoft.com/office/drawing/2014/main" id="{BD4C1B19-0823-6605-43C1-E446400E3CAD}"/>
+              </a:ext>
+            </a:extLst>
+          </p:cNvPr>
+          <p:cNvPicPr>
+            <a:picLocks noChangeAspect="1"/>
+          </p:cNvPicPr>
+          <p:nvPr/>
+        </p:nvPicPr>
+        <p:blipFill>
+          <a:blip r:embed="rId5"/>
+          <a:stretch>
+            <a:fillRect/>
+          </a:stretch>
+        </p:blipFill>
+        <p:spPr>
+          <a:xfrm>
+            <a:off x="4431438" y="2820673"/>
+            <a:ext cx="4201111" cy="1581371"/>
+          </a:xfrm>
+          <a:prstGeom prst="rect">
+            <a:avLst/>
+          </a:prstGeom>
+        </p:spPr>
+      </p:pic>
+    </p:spTree>
+    <p:extLst>
+      <p:ext uri="{BB962C8B-B14F-4D97-AF65-F5344CB8AC3E}">
+        <p14:creationId xmlns:p14="http://schemas.microsoft.com/office/powerpoint/2010/main" val="1669074784"/>
+      </p:ext>
+    </p:extLst>
+  </p:cSld>
+  <p:clrMapOvr>
+    <a:masterClrMapping/>
+  </p:clrMapOvr>
+</p:sld>
+</file>
+
+<file path=ppt/slides/slide6.xml><?xml version="1.0" encoding="utf-8"?>
+<p:sld xmlns:a="http://schemas.openxmlformats.org/drawingml/2006/main" xmlns:r="http://schemas.openxmlformats.org/officeDocument/2006/relationships" xmlns:p="http://schemas.openxmlformats.org/presentationml/2006/main">
+  <p:cSld>
+    <p:spTree>
+      <p:nvGrpSpPr>
+        <p:cNvPr id="1" name=""/>
+        <p:cNvGrpSpPr/>
+        <p:nvPr/>
+      </p:nvGrpSpPr>
+      <p:grpSpPr>
+        <a:xfrm>
+          <a:off x="0" y="0"/>
+          <a:ext cx="0" cy="0"/>
+          <a:chOff x="0" y="0"/>
+          <a:chExt cx="0" cy="0"/>
+        </a:xfrm>
+      </p:grpSpPr>
+      <p:sp>
+        <p:nvSpPr>
+          <p:cNvPr id="15" name="TextBox 14">
+            <a:extLst>
+              <a:ext uri="{FF2B5EF4-FFF2-40B4-BE49-F238E27FC236}">
+                <a16:creationId xmlns:a16="http://schemas.microsoft.com/office/drawing/2014/main" id="{3F1E0228-947C-4D61-6E05-E82BEB8A66EF}"/>
+              </a:ext>
+            </a:extLst>
+          </p:cNvPr>
+          <p:cNvSpPr txBox="1"/>
+          <p:nvPr/>
+        </p:nvSpPr>
+        <p:spPr>
+          <a:xfrm>
+            <a:off x="6094396" y="393327"/>
+            <a:ext cx="6055894" cy="4824041"/>
+          </a:xfrm>
+          <a:prstGeom prst="rect">
+            <a:avLst/>
+          </a:prstGeom>
+          <a:solidFill>
+            <a:schemeClr val="tx1"/>
+          </a:solidFill>
+        </p:spPr>
+        <p:txBody>
+          <a:bodyPr wrap="square">
+            <a:spAutoFit/>
+          </a:bodyPr>
+          <a:lstStyle/>
+          <a:p>
+            <a:pPr>
+              <a:buNone/>
+            </a:pPr>
+            <a:r>
+              <a:rPr lang="en-US" altLang="ko-KR" sz="1000">
+                <a:solidFill>
+                  <a:srgbClr val="CF8E6D"/>
+                </a:solidFill>
+                <a:effectLst/>
+                <a:latin typeface="JetBrains Mono"/>
+              </a:rPr>
+              <a:t>healthcheck</a:t>
+            </a:r>
+            <a:r>
+              <a:rPr lang="en-US" altLang="ko-KR" sz="1000">
+                <a:solidFill>
+                  <a:srgbClr val="BCBEC4"/>
+                </a:solidFill>
+                <a:effectLst/>
+                <a:latin typeface="JetBrains Mono"/>
+              </a:rPr>
+              <a:t>:</a:t>
+            </a:r>
+            <a:br>
+              <a:rPr lang="en-US" altLang="ko-KR" sz="1000">
+                <a:solidFill>
+                  <a:srgbClr val="BCBEC4"/>
+                </a:solidFill>
+                <a:effectLst/>
+                <a:latin typeface="JetBrains Mono"/>
+              </a:rPr>
+            </a:br>
+            <a:r>
+              <a:rPr lang="en-US" altLang="ko-KR" sz="1000">
+                <a:solidFill>
+                  <a:srgbClr val="BCBEC4"/>
+                </a:solidFill>
+                <a:effectLst/>
+                <a:latin typeface="JetBrains Mono"/>
+              </a:rPr>
+              <a:t>      </a:t>
+            </a:r>
+            <a:r>
+              <a:rPr lang="en-US" altLang="ko-KR" sz="1000" i="1">
+                <a:solidFill>
+                  <a:srgbClr val="5F826B"/>
+                </a:solidFill>
+                <a:effectLst/>
+                <a:latin typeface="JetBrains Mono"/>
+              </a:rPr>
+              <a:t># </a:t>
+            </a:r>
+            <a:r>
+              <a:rPr lang="ko-KR" altLang="en-US" sz="1000" i="1">
+                <a:solidFill>
+                  <a:srgbClr val="5F826B"/>
+                </a:solidFill>
+                <a:effectLst/>
+                <a:latin typeface="Courier New" panose="02070309020205020404" pitchFamily="49" charset="0"/>
+              </a:rPr>
+              <a:t>✅ 내부에서 외부 리스너로 체크해도 되고</a:t>
+            </a:r>
+            <a:r>
+              <a:rPr lang="en-US" altLang="ko-KR" sz="1000" i="1">
+                <a:solidFill>
+                  <a:srgbClr val="5F826B"/>
+                </a:solidFill>
+                <a:effectLst/>
+                <a:latin typeface="JetBrains Mono"/>
+              </a:rPr>
+              <a:t>, internal://9092</a:t>
+            </a:r>
+            <a:r>
+              <a:rPr lang="ko-KR" altLang="en-US" sz="1000" i="1">
+                <a:solidFill>
+                  <a:srgbClr val="5F826B"/>
+                </a:solidFill>
+                <a:effectLst/>
+                <a:latin typeface="Courier New" panose="02070309020205020404" pitchFamily="49" charset="0"/>
+              </a:rPr>
+              <a:t>로 해도 됨</a:t>
+            </a:r>
+            <a:br>
+              <a:rPr lang="ko-KR" altLang="en-US" sz="1000" i="1">
+                <a:solidFill>
+                  <a:srgbClr val="5F826B"/>
+                </a:solidFill>
+                <a:effectLst/>
+                <a:latin typeface="Courier New" panose="02070309020205020404" pitchFamily="49" charset="0"/>
+              </a:rPr>
+            </a:br>
+            <a:r>
+              <a:rPr lang="ko-KR" altLang="en-US" sz="1000" i="1">
+                <a:solidFill>
+                  <a:srgbClr val="5F826B"/>
+                </a:solidFill>
+                <a:effectLst/>
+                <a:latin typeface="Courier New" panose="02070309020205020404" pitchFamily="49" charset="0"/>
+              </a:rPr>
+              <a:t>      </a:t>
+            </a:r>
+            <a:r>
+              <a:rPr lang="en-US" altLang="ko-KR" sz="1000" i="1">
+                <a:solidFill>
+                  <a:srgbClr val="5F826B"/>
+                </a:solidFill>
+                <a:effectLst/>
+                <a:latin typeface="JetBrains Mono"/>
+              </a:rPr>
+              <a:t># </a:t>
+            </a:r>
+            <a:r>
+              <a:rPr lang="ko-KR" altLang="en-US" sz="1000" i="1">
+                <a:solidFill>
+                  <a:srgbClr val="5F826B"/>
+                </a:solidFill>
+                <a:effectLst/>
+                <a:latin typeface="Courier New" panose="02070309020205020404" pitchFamily="49" charset="0"/>
+              </a:rPr>
+              <a:t>여기서는 기존 의도 유지</a:t>
+            </a:r>
+            <a:br>
+              <a:rPr lang="ko-KR" altLang="en-US" sz="1000" i="1">
+                <a:solidFill>
+                  <a:srgbClr val="5F826B"/>
+                </a:solidFill>
+                <a:effectLst/>
+                <a:latin typeface="Courier New" panose="02070309020205020404" pitchFamily="49" charset="0"/>
+              </a:rPr>
+            </a:br>
+            <a:r>
+              <a:rPr lang="ko-KR" altLang="en-US" sz="1000" i="1">
+                <a:solidFill>
+                  <a:srgbClr val="5F826B"/>
+                </a:solidFill>
+                <a:effectLst/>
+                <a:latin typeface="Courier New" panose="02070309020205020404" pitchFamily="49" charset="0"/>
+              </a:rPr>
+              <a:t>      </a:t>
+            </a:r>
+            <a:r>
+              <a:rPr lang="en-US" altLang="ko-KR" sz="1000">
+                <a:solidFill>
+                  <a:srgbClr val="CF8E6D"/>
+                </a:solidFill>
+                <a:effectLst/>
+                <a:latin typeface="JetBrains Mono"/>
+              </a:rPr>
+              <a:t>test</a:t>
+            </a:r>
+            <a:r>
+              <a:rPr lang="en-US" altLang="ko-KR" sz="1000">
+                <a:solidFill>
+                  <a:srgbClr val="BCBEC4"/>
+                </a:solidFill>
+                <a:effectLst/>
+                <a:latin typeface="JetBrains Mono"/>
+              </a:rPr>
+              <a:t>: [</a:t>
+            </a:r>
+            <a:r>
+              <a:rPr lang="en-US" altLang="ko-KR" sz="1000">
+                <a:solidFill>
+                  <a:srgbClr val="6AAB73"/>
+                </a:solidFill>
+                <a:effectLst/>
+                <a:latin typeface="JetBrains Mono"/>
+              </a:rPr>
+              <a:t>"CMD-SHELL"</a:t>
+            </a:r>
+            <a:r>
+              <a:rPr lang="en-US" altLang="ko-KR" sz="1000">
+                <a:solidFill>
+                  <a:srgbClr val="BCBEC4"/>
+                </a:solidFill>
+                <a:effectLst/>
+                <a:latin typeface="JetBrains Mono"/>
+              </a:rPr>
+              <a:t>, </a:t>
+            </a:r>
+            <a:r>
+              <a:rPr lang="en-US" altLang="ko-KR" sz="1000">
+                <a:solidFill>
+                  <a:srgbClr val="6AAB73"/>
+                </a:solidFill>
+                <a:effectLst/>
+                <a:latin typeface="JetBrains Mono"/>
+              </a:rPr>
+              <a:t>"rpk cluster health -X brokers=localhost:19092 || exit 1"</a:t>
+            </a:r>
+            <a:r>
+              <a:rPr lang="en-US" altLang="ko-KR" sz="1000">
+                <a:solidFill>
+                  <a:srgbClr val="BCBEC4"/>
+                </a:solidFill>
+                <a:effectLst/>
+                <a:latin typeface="JetBrains Mono"/>
+              </a:rPr>
+              <a:t>]</a:t>
+            </a:r>
+            <a:br>
+              <a:rPr lang="en-US" altLang="ko-KR" sz="1000">
+                <a:solidFill>
+                  <a:srgbClr val="BCBEC4"/>
+                </a:solidFill>
+                <a:effectLst/>
+                <a:latin typeface="JetBrains Mono"/>
+              </a:rPr>
+            </a:br>
+            <a:r>
+              <a:rPr lang="en-US" altLang="ko-KR" sz="1000">
+                <a:solidFill>
+                  <a:srgbClr val="BCBEC4"/>
+                </a:solidFill>
+                <a:effectLst/>
+                <a:latin typeface="JetBrains Mono"/>
+              </a:rPr>
+              <a:t>      </a:t>
+            </a:r>
+            <a:r>
+              <a:rPr lang="en-US" altLang="ko-KR" sz="1000">
+                <a:solidFill>
+                  <a:srgbClr val="CF8E6D"/>
+                </a:solidFill>
+                <a:effectLst/>
+                <a:latin typeface="JetBrains Mono"/>
+              </a:rPr>
+              <a:t>interval</a:t>
+            </a:r>
+            <a:r>
+              <a:rPr lang="en-US" altLang="ko-KR" sz="1000">
+                <a:solidFill>
+                  <a:srgbClr val="BCBEC4"/>
+                </a:solidFill>
+                <a:effectLst/>
+                <a:latin typeface="JetBrains Mono"/>
+              </a:rPr>
+              <a:t>: 5s</a:t>
+            </a:r>
+            <a:br>
+              <a:rPr lang="en-US" altLang="ko-KR" sz="1000">
+                <a:solidFill>
+                  <a:srgbClr val="BCBEC4"/>
+                </a:solidFill>
+                <a:effectLst/>
+                <a:latin typeface="JetBrains Mono"/>
+              </a:rPr>
+            </a:br>
+            <a:r>
+              <a:rPr lang="en-US" altLang="ko-KR" sz="1000">
+                <a:solidFill>
+                  <a:srgbClr val="BCBEC4"/>
+                </a:solidFill>
+                <a:effectLst/>
+                <a:latin typeface="JetBrains Mono"/>
+              </a:rPr>
+              <a:t>      </a:t>
+            </a:r>
+            <a:r>
+              <a:rPr lang="en-US" altLang="ko-KR" sz="1000">
+                <a:solidFill>
+                  <a:srgbClr val="CF8E6D"/>
+                </a:solidFill>
+                <a:effectLst/>
+                <a:latin typeface="JetBrains Mono"/>
+              </a:rPr>
+              <a:t>timeout</a:t>
+            </a:r>
+            <a:r>
+              <a:rPr lang="en-US" altLang="ko-KR" sz="1000">
+                <a:solidFill>
+                  <a:srgbClr val="BCBEC4"/>
+                </a:solidFill>
+                <a:effectLst/>
+                <a:latin typeface="JetBrains Mono"/>
+              </a:rPr>
+              <a:t>: 3s</a:t>
+            </a:r>
+            <a:br>
+              <a:rPr lang="en-US" altLang="ko-KR" sz="1000">
+                <a:solidFill>
+                  <a:srgbClr val="BCBEC4"/>
+                </a:solidFill>
+                <a:effectLst/>
+                <a:latin typeface="JetBrains Mono"/>
+              </a:rPr>
+            </a:br>
+            <a:r>
+              <a:rPr lang="en-US" altLang="ko-KR" sz="1000">
+                <a:solidFill>
+                  <a:srgbClr val="BCBEC4"/>
+                </a:solidFill>
+                <a:effectLst/>
+                <a:latin typeface="JetBrains Mono"/>
+              </a:rPr>
+              <a:t>      </a:t>
+            </a:r>
+            <a:r>
+              <a:rPr lang="en-US" altLang="ko-KR" sz="1000">
+                <a:solidFill>
+                  <a:srgbClr val="CF8E6D"/>
+                </a:solidFill>
+                <a:effectLst/>
+                <a:latin typeface="JetBrains Mono"/>
+              </a:rPr>
+              <a:t>retries</a:t>
+            </a:r>
+            <a:r>
+              <a:rPr lang="en-US" altLang="ko-KR" sz="1000">
+                <a:solidFill>
+                  <a:srgbClr val="BCBEC4"/>
+                </a:solidFill>
+                <a:effectLst/>
+                <a:latin typeface="JetBrains Mono"/>
+              </a:rPr>
+              <a:t>: 20</a:t>
+            </a:r>
+            <a:br>
+              <a:rPr lang="en-US" altLang="ko-KR" sz="1000">
+                <a:solidFill>
+                  <a:srgbClr val="BCBEC4"/>
+                </a:solidFill>
+                <a:effectLst/>
+                <a:latin typeface="JetBrains Mono"/>
+              </a:rPr>
+            </a:br>
+            <a:br>
+              <a:rPr lang="en-US" altLang="ko-KR" sz="1000">
+                <a:solidFill>
+                  <a:srgbClr val="BCBEC4"/>
+                </a:solidFill>
+                <a:effectLst/>
+                <a:latin typeface="JetBrains Mono"/>
+              </a:rPr>
+            </a:br>
+            <a:r>
+              <a:rPr lang="en-US" altLang="ko-KR" sz="1000">
+                <a:solidFill>
+                  <a:srgbClr val="BCBEC4"/>
+                </a:solidFill>
+                <a:effectLst/>
+                <a:latin typeface="JetBrains Mono"/>
+              </a:rPr>
+              <a:t>  </a:t>
+            </a:r>
+            <a:r>
+              <a:rPr lang="en-US" altLang="ko-KR" sz="1000">
+                <a:solidFill>
+                  <a:srgbClr val="CF8E6D"/>
+                </a:solidFill>
+                <a:effectLst/>
+                <a:latin typeface="JetBrains Mono"/>
+              </a:rPr>
+              <a:t>console</a:t>
+            </a:r>
+            <a:r>
+              <a:rPr lang="en-US" altLang="ko-KR" sz="1000">
+                <a:solidFill>
+                  <a:srgbClr val="BCBEC4"/>
+                </a:solidFill>
+                <a:effectLst/>
+                <a:latin typeface="JetBrains Mono"/>
+              </a:rPr>
+              <a:t>:</a:t>
+            </a:r>
+            <a:br>
+              <a:rPr lang="en-US" altLang="ko-KR" sz="1000">
+                <a:solidFill>
+                  <a:srgbClr val="BCBEC4"/>
+                </a:solidFill>
+                <a:effectLst/>
+                <a:latin typeface="JetBrains Mono"/>
+              </a:rPr>
+            </a:br>
+            <a:r>
+              <a:rPr lang="en-US" altLang="ko-KR" sz="1000">
+                <a:solidFill>
+                  <a:srgbClr val="BCBEC4"/>
+                </a:solidFill>
+                <a:effectLst/>
+                <a:latin typeface="JetBrains Mono"/>
+              </a:rPr>
+              <a:t>    </a:t>
+            </a:r>
+            <a:r>
+              <a:rPr lang="en-US" altLang="ko-KR" sz="1000">
+                <a:solidFill>
+                  <a:srgbClr val="CF8E6D"/>
+                </a:solidFill>
+                <a:effectLst/>
+                <a:latin typeface="JetBrains Mono"/>
+              </a:rPr>
+              <a:t>image</a:t>
+            </a:r>
+            <a:r>
+              <a:rPr lang="en-US" altLang="ko-KR" sz="1000">
+                <a:solidFill>
+                  <a:srgbClr val="BCBEC4"/>
+                </a:solidFill>
+                <a:effectLst/>
+                <a:latin typeface="JetBrains Mono"/>
+              </a:rPr>
+              <a:t>: docker.redpanda.com/redpandadata/console:latest</a:t>
+            </a:r>
+            <a:br>
+              <a:rPr lang="en-US" altLang="ko-KR" sz="1000">
+                <a:solidFill>
+                  <a:srgbClr val="BCBEC4"/>
+                </a:solidFill>
+                <a:effectLst/>
+                <a:latin typeface="JetBrains Mono"/>
+              </a:rPr>
+            </a:br>
+            <a:r>
+              <a:rPr lang="en-US" altLang="ko-KR" sz="1000">
+                <a:solidFill>
+                  <a:srgbClr val="BCBEC4"/>
+                </a:solidFill>
+                <a:effectLst/>
+                <a:latin typeface="JetBrains Mono"/>
+              </a:rPr>
+              <a:t>    </a:t>
+            </a:r>
+            <a:r>
+              <a:rPr lang="en-US" altLang="ko-KR" sz="1000">
+                <a:solidFill>
+                  <a:srgbClr val="CF8E6D"/>
+                </a:solidFill>
+                <a:effectLst/>
+                <a:latin typeface="JetBrains Mono"/>
+              </a:rPr>
+              <a:t>ports</a:t>
+            </a:r>
+            <a:r>
+              <a:rPr lang="en-US" altLang="ko-KR" sz="1000">
+                <a:solidFill>
+                  <a:srgbClr val="BCBEC4"/>
+                </a:solidFill>
+                <a:effectLst/>
+                <a:latin typeface="JetBrains Mono"/>
+              </a:rPr>
+              <a:t>:</a:t>
+            </a:r>
+            <a:br>
+              <a:rPr lang="en-US" altLang="ko-KR" sz="1000">
+                <a:solidFill>
+                  <a:srgbClr val="BCBEC4"/>
+                </a:solidFill>
+                <a:effectLst/>
+                <a:latin typeface="JetBrains Mono"/>
+              </a:rPr>
+            </a:br>
+            <a:r>
+              <a:rPr lang="en-US" altLang="ko-KR" sz="1000">
+                <a:solidFill>
+                  <a:srgbClr val="BCBEC4"/>
+                </a:solidFill>
+                <a:effectLst/>
+                <a:latin typeface="JetBrains Mono"/>
+              </a:rPr>
+              <a:t>      - </a:t>
+            </a:r>
+            <a:r>
+              <a:rPr lang="en-US" altLang="ko-KR" sz="1000">
+                <a:solidFill>
+                  <a:srgbClr val="6AAB73"/>
+                </a:solidFill>
+                <a:effectLst/>
+                <a:latin typeface="JetBrains Mono"/>
+              </a:rPr>
+              <a:t>"8090:8080"</a:t>
+            </a:r>
+            <a:br>
+              <a:rPr lang="en-US" altLang="ko-KR" sz="1000">
+                <a:solidFill>
+                  <a:srgbClr val="6AAB73"/>
+                </a:solidFill>
+                <a:effectLst/>
+                <a:latin typeface="JetBrains Mono"/>
+              </a:rPr>
+            </a:br>
+            <a:r>
+              <a:rPr lang="en-US" altLang="ko-KR" sz="1000">
+                <a:solidFill>
+                  <a:srgbClr val="6AAB73"/>
+                </a:solidFill>
+                <a:effectLst/>
+                <a:latin typeface="JetBrains Mono"/>
+              </a:rPr>
+              <a:t>    </a:t>
+            </a:r>
+            <a:r>
+              <a:rPr lang="en-US" altLang="ko-KR" sz="1000">
+                <a:solidFill>
+                  <a:srgbClr val="CF8E6D"/>
+                </a:solidFill>
+                <a:effectLst/>
+                <a:latin typeface="JetBrains Mono"/>
+              </a:rPr>
+              <a:t>entrypoint</a:t>
+            </a:r>
+            <a:r>
+              <a:rPr lang="en-US" altLang="ko-KR" sz="1000">
+                <a:solidFill>
+                  <a:srgbClr val="BCBEC4"/>
+                </a:solidFill>
+                <a:effectLst/>
+                <a:latin typeface="JetBrains Mono"/>
+              </a:rPr>
+              <a:t>: /bin/sh</a:t>
+            </a:r>
+            <a:br>
+              <a:rPr lang="en-US" altLang="ko-KR" sz="1000">
+                <a:solidFill>
+                  <a:srgbClr val="BCBEC4"/>
+                </a:solidFill>
+                <a:effectLst/>
+                <a:latin typeface="JetBrains Mono"/>
+              </a:rPr>
+            </a:br>
+            <a:r>
+              <a:rPr lang="en-US" altLang="ko-KR" sz="1000">
+                <a:solidFill>
+                  <a:srgbClr val="BCBEC4"/>
+                </a:solidFill>
+                <a:effectLst/>
+                <a:latin typeface="JetBrains Mono"/>
+              </a:rPr>
+              <a:t>    </a:t>
+            </a:r>
+            <a:r>
+              <a:rPr lang="en-US" altLang="ko-KR" sz="1000">
+                <a:solidFill>
+                  <a:srgbClr val="CF8E6D"/>
+                </a:solidFill>
+                <a:effectLst/>
+                <a:latin typeface="JetBrains Mono"/>
+              </a:rPr>
+              <a:t>command</a:t>
+            </a:r>
+            <a:r>
+              <a:rPr lang="en-US" altLang="ko-KR" sz="1000">
+                <a:solidFill>
+                  <a:srgbClr val="BCBEC4"/>
+                </a:solidFill>
+                <a:effectLst/>
+                <a:latin typeface="JetBrains Mono"/>
+              </a:rPr>
+              <a:t>: -c 'echo "$$CONSOLE_CONFIG_FILE" &gt; /tmp/config.yml; /app/console'</a:t>
+            </a:r>
+            <a:br>
+              <a:rPr lang="en-US" altLang="ko-KR" sz="1000">
+                <a:solidFill>
+                  <a:srgbClr val="BCBEC4"/>
+                </a:solidFill>
+                <a:effectLst/>
+                <a:latin typeface="JetBrains Mono"/>
+              </a:rPr>
+            </a:br>
+            <a:r>
+              <a:rPr lang="en-US" altLang="ko-KR" sz="1000">
+                <a:solidFill>
+                  <a:srgbClr val="BCBEC4"/>
+                </a:solidFill>
+                <a:effectLst/>
+                <a:latin typeface="JetBrains Mono"/>
+              </a:rPr>
+              <a:t>    </a:t>
+            </a:r>
+            <a:r>
+              <a:rPr lang="en-US" altLang="ko-KR" sz="1000">
+                <a:solidFill>
+                  <a:srgbClr val="CF8E6D"/>
+                </a:solidFill>
+                <a:effectLst/>
+                <a:latin typeface="JetBrains Mono"/>
+              </a:rPr>
+              <a:t>environment</a:t>
+            </a:r>
+            <a:r>
+              <a:rPr lang="en-US" altLang="ko-KR" sz="1000">
+                <a:solidFill>
+                  <a:srgbClr val="BCBEC4"/>
+                </a:solidFill>
+                <a:effectLst/>
+                <a:latin typeface="JetBrains Mono"/>
+              </a:rPr>
+              <a:t>:</a:t>
+            </a:r>
+            <a:br>
+              <a:rPr lang="en-US" altLang="ko-KR" sz="1000">
+                <a:solidFill>
+                  <a:srgbClr val="BCBEC4"/>
+                </a:solidFill>
+                <a:effectLst/>
+                <a:latin typeface="JetBrains Mono"/>
+              </a:rPr>
+            </a:br>
+            <a:r>
+              <a:rPr lang="en-US" altLang="ko-KR" sz="1000">
+                <a:solidFill>
+                  <a:srgbClr val="BCBEC4"/>
+                </a:solidFill>
+                <a:effectLst/>
+                <a:latin typeface="JetBrains Mono"/>
+              </a:rPr>
+              <a:t>      </a:t>
+            </a:r>
+            <a:r>
+              <a:rPr lang="en-US" altLang="ko-KR" sz="1000">
+                <a:solidFill>
+                  <a:srgbClr val="CF8E6D"/>
+                </a:solidFill>
+                <a:effectLst/>
+                <a:latin typeface="JetBrains Mono"/>
+              </a:rPr>
+              <a:t>CONFIG_FILEPATH</a:t>
+            </a:r>
+            <a:r>
+              <a:rPr lang="en-US" altLang="ko-KR" sz="1000">
+                <a:solidFill>
+                  <a:srgbClr val="BCBEC4"/>
+                </a:solidFill>
+                <a:effectLst/>
+                <a:latin typeface="JetBrains Mono"/>
+              </a:rPr>
+              <a:t>: /tmp/config.yml</a:t>
+            </a:r>
+            <a:br>
+              <a:rPr lang="en-US" altLang="ko-KR" sz="1000">
+                <a:solidFill>
+                  <a:srgbClr val="BCBEC4"/>
+                </a:solidFill>
+                <a:effectLst/>
+                <a:latin typeface="JetBrains Mono"/>
+              </a:rPr>
+            </a:br>
+            <a:r>
+              <a:rPr lang="en-US" altLang="ko-KR" sz="1000">
+                <a:solidFill>
+                  <a:srgbClr val="BCBEC4"/>
+                </a:solidFill>
+                <a:effectLst/>
+                <a:latin typeface="JetBrains Mono"/>
+              </a:rPr>
+              <a:t>      </a:t>
+            </a:r>
+            <a:r>
+              <a:rPr lang="en-US" altLang="ko-KR" sz="1000">
+                <a:solidFill>
+                  <a:srgbClr val="CF8E6D"/>
+                </a:solidFill>
+                <a:effectLst/>
+                <a:latin typeface="JetBrains Mono"/>
+              </a:rPr>
+              <a:t>CONSOLE_CONFIG_FILE</a:t>
+            </a:r>
+            <a:r>
+              <a:rPr lang="en-US" altLang="ko-KR" sz="1000">
+                <a:solidFill>
+                  <a:srgbClr val="BCBEC4"/>
+                </a:solidFill>
+                <a:effectLst/>
+                <a:latin typeface="JetBrains Mono"/>
+              </a:rPr>
+              <a:t>: |</a:t>
+            </a:r>
+            <a:br>
+              <a:rPr lang="en-US" altLang="ko-KR" sz="1000">
+                <a:solidFill>
+                  <a:srgbClr val="BCBEC4"/>
+                </a:solidFill>
+                <a:effectLst/>
+                <a:latin typeface="JetBrains Mono"/>
+              </a:rPr>
+            </a:br>
+            <a:r>
+              <a:rPr lang="en-US" altLang="ko-KR" sz="1000">
+                <a:solidFill>
+                  <a:srgbClr val="BCBEC4"/>
+                </a:solidFill>
+                <a:effectLst/>
+                <a:latin typeface="JetBrains Mono"/>
+              </a:rPr>
+              <a:t>        kafka:</a:t>
+            </a:r>
+            <a:br>
+              <a:rPr lang="en-US" altLang="ko-KR" sz="1000">
+                <a:solidFill>
+                  <a:srgbClr val="BCBEC4"/>
+                </a:solidFill>
+                <a:effectLst/>
+                <a:latin typeface="JetBrains Mono"/>
+              </a:rPr>
+            </a:br>
+            <a:r>
+              <a:rPr lang="en-US" altLang="ko-KR" sz="1000">
+                <a:solidFill>
+                  <a:srgbClr val="BCBEC4"/>
+                </a:solidFill>
+                <a:effectLst/>
+                <a:latin typeface="JetBrains Mono"/>
+              </a:rPr>
+              <a:t>          brokers: ["redpanda:9092"]        # </a:t>
+            </a:r>
+            <a:r>
+              <a:rPr lang="ko-KR" altLang="en-US" sz="1000">
+                <a:solidFill>
+                  <a:srgbClr val="BCBEC4"/>
+                </a:solidFill>
+                <a:effectLst/>
+                <a:latin typeface="Courier New" panose="02070309020205020404" pitchFamily="49" charset="0"/>
+              </a:rPr>
+              <a:t>✅ 도커 내부 클라이언트는</a:t>
+            </a:r>
+            <a:r>
+              <a:rPr lang="ko-KR" altLang="en-US" sz="1000">
+                <a:solidFill>
+                  <a:srgbClr val="BCBEC4"/>
+                </a:solidFill>
+                <a:effectLst/>
+                <a:latin typeface="JetBrains Mono"/>
+              </a:rPr>
+              <a:t> </a:t>
+            </a:r>
+            <a:r>
+              <a:rPr lang="en-US" altLang="ko-KR" sz="1000">
+                <a:solidFill>
+                  <a:srgbClr val="BCBEC4"/>
+                </a:solidFill>
+                <a:effectLst/>
+                <a:latin typeface="JetBrains Mono"/>
+              </a:rPr>
+              <a:t>internal </a:t>
+            </a:r>
+            <a:r>
+              <a:rPr lang="ko-KR" altLang="en-US" sz="1000">
+                <a:solidFill>
+                  <a:srgbClr val="BCBEC4"/>
+                </a:solidFill>
+                <a:effectLst/>
+                <a:latin typeface="Courier New" panose="02070309020205020404" pitchFamily="49" charset="0"/>
+              </a:rPr>
+              <a:t>리스너 사용</a:t>
+            </a:r>
+            <a:br>
+              <a:rPr lang="ko-KR" altLang="en-US" sz="1000">
+                <a:solidFill>
+                  <a:srgbClr val="BCBEC4"/>
+                </a:solidFill>
+                <a:effectLst/>
+                <a:latin typeface="Courier New" panose="02070309020205020404" pitchFamily="49" charset="0"/>
+              </a:rPr>
+            </a:br>
+            <a:r>
+              <a:rPr lang="ko-KR" altLang="en-US" sz="1000">
+                <a:solidFill>
+                  <a:srgbClr val="BCBEC4"/>
+                </a:solidFill>
+                <a:effectLst/>
+                <a:latin typeface="Courier New" panose="02070309020205020404" pitchFamily="49" charset="0"/>
+              </a:rPr>
+              <a:t>        </a:t>
+            </a:r>
+            <a:r>
+              <a:rPr lang="en-US" altLang="ko-KR" sz="1000">
+                <a:solidFill>
+                  <a:srgbClr val="BCBEC4"/>
+                </a:solidFill>
+                <a:effectLst/>
+                <a:latin typeface="JetBrains Mono"/>
+              </a:rPr>
+              <a:t>redpanda:</a:t>
+            </a:r>
+            <a:br>
+              <a:rPr lang="en-US" altLang="ko-KR" sz="1000">
+                <a:solidFill>
+                  <a:srgbClr val="BCBEC4"/>
+                </a:solidFill>
+                <a:effectLst/>
+                <a:latin typeface="JetBrains Mono"/>
+              </a:rPr>
+            </a:br>
+            <a:r>
+              <a:rPr lang="en-US" altLang="ko-KR" sz="1000">
+                <a:solidFill>
+                  <a:srgbClr val="BCBEC4"/>
+                </a:solidFill>
+                <a:effectLst/>
+                <a:latin typeface="JetBrains Mono"/>
+              </a:rPr>
+              <a:t>          adminApi:</a:t>
+            </a:r>
+            <a:br>
+              <a:rPr lang="en-US" altLang="ko-KR" sz="1000">
+                <a:solidFill>
+                  <a:srgbClr val="BCBEC4"/>
+                </a:solidFill>
+                <a:effectLst/>
+                <a:latin typeface="JetBrains Mono"/>
+              </a:rPr>
+            </a:br>
+            <a:r>
+              <a:rPr lang="en-US" altLang="ko-KR" sz="1000">
+                <a:solidFill>
+                  <a:srgbClr val="BCBEC4"/>
+                </a:solidFill>
+                <a:effectLst/>
+                <a:latin typeface="JetBrains Mono"/>
+              </a:rPr>
+              <a:t>            enabled: true</a:t>
+            </a:r>
+            <a:br>
+              <a:rPr lang="en-US" altLang="ko-KR" sz="1000">
+                <a:solidFill>
+                  <a:srgbClr val="BCBEC4"/>
+                </a:solidFill>
+                <a:effectLst/>
+                <a:latin typeface="JetBrains Mono"/>
+              </a:rPr>
+            </a:br>
+            <a:r>
+              <a:rPr lang="en-US" altLang="ko-KR" sz="1000">
+                <a:solidFill>
+                  <a:srgbClr val="BCBEC4"/>
+                </a:solidFill>
+                <a:effectLst/>
+                <a:latin typeface="JetBrains Mono"/>
+              </a:rPr>
+              <a:t>            urls: ["http://redpanda:9644"]  # </a:t>
+            </a:r>
+            <a:r>
+              <a:rPr lang="ko-KR" altLang="en-US" sz="1000">
+                <a:solidFill>
+                  <a:srgbClr val="BCBEC4"/>
+                </a:solidFill>
+                <a:effectLst/>
+                <a:latin typeface="Courier New" panose="02070309020205020404" pitchFamily="49" charset="0"/>
+              </a:rPr>
+              <a:t>✅ 도커 내부에서</a:t>
+            </a:r>
+            <a:r>
+              <a:rPr lang="ko-KR" altLang="en-US" sz="1000">
+                <a:solidFill>
+                  <a:srgbClr val="BCBEC4"/>
+                </a:solidFill>
+                <a:effectLst/>
+                <a:latin typeface="JetBrains Mono"/>
+              </a:rPr>
+              <a:t> </a:t>
+            </a:r>
+            <a:r>
+              <a:rPr lang="en-US" altLang="ko-KR" sz="1000">
+                <a:solidFill>
+                  <a:srgbClr val="BCBEC4"/>
+                </a:solidFill>
+                <a:effectLst/>
+                <a:latin typeface="JetBrains Mono"/>
+              </a:rPr>
+              <a:t>admin api </a:t>
+            </a:r>
+            <a:r>
+              <a:rPr lang="ko-KR" altLang="en-US" sz="1000">
+                <a:solidFill>
+                  <a:srgbClr val="BCBEC4"/>
+                </a:solidFill>
+                <a:effectLst/>
+                <a:latin typeface="Courier New" panose="02070309020205020404" pitchFamily="49" charset="0"/>
+              </a:rPr>
+              <a:t>접근</a:t>
+            </a:r>
+            <a:br>
+              <a:rPr lang="ko-KR" altLang="en-US" sz="1000">
+                <a:solidFill>
+                  <a:srgbClr val="BCBEC4"/>
+                </a:solidFill>
+                <a:effectLst/>
+                <a:latin typeface="Courier New" panose="02070309020205020404" pitchFamily="49" charset="0"/>
+              </a:rPr>
+            </a:br>
+            <a:br>
+              <a:rPr lang="ko-KR" altLang="en-US" sz="1000">
+                <a:solidFill>
+                  <a:srgbClr val="BCBEC4"/>
+                </a:solidFill>
+                <a:effectLst/>
+                <a:latin typeface="Courier New" panose="02070309020205020404" pitchFamily="49" charset="0"/>
+              </a:rPr>
+            </a:br>
+            <a:r>
+              <a:rPr lang="ko-KR" altLang="en-US" sz="1000">
+                <a:solidFill>
+                  <a:srgbClr val="BCBEC4"/>
+                </a:solidFill>
+                <a:effectLst/>
+                <a:latin typeface="Courier New" panose="02070309020205020404" pitchFamily="49" charset="0"/>
+              </a:rPr>
+              <a:t>    </a:t>
+            </a:r>
+            <a:r>
+              <a:rPr lang="en-US" altLang="ko-KR" sz="1000">
+                <a:solidFill>
+                  <a:srgbClr val="CF8E6D"/>
+                </a:solidFill>
+                <a:effectLst/>
+                <a:latin typeface="JetBrains Mono"/>
+              </a:rPr>
+              <a:t>depends_on</a:t>
+            </a:r>
+            <a:r>
+              <a:rPr lang="en-US" altLang="ko-KR" sz="1000">
+                <a:solidFill>
+                  <a:srgbClr val="BCBEC4"/>
+                </a:solidFill>
+                <a:effectLst/>
+                <a:latin typeface="JetBrains Mono"/>
+              </a:rPr>
+              <a:t>:</a:t>
+            </a:r>
+            <a:br>
+              <a:rPr lang="en-US" altLang="ko-KR" sz="1000">
+                <a:solidFill>
+                  <a:srgbClr val="BCBEC4"/>
+                </a:solidFill>
+                <a:effectLst/>
+                <a:latin typeface="JetBrains Mono"/>
+              </a:rPr>
+            </a:br>
+            <a:r>
+              <a:rPr lang="en-US" altLang="ko-KR" sz="1000">
+                <a:solidFill>
+                  <a:srgbClr val="BCBEC4"/>
+                </a:solidFill>
+                <a:effectLst/>
+                <a:latin typeface="JetBrains Mono"/>
+              </a:rPr>
+              <a:t>      </a:t>
+            </a:r>
+            <a:r>
+              <a:rPr lang="en-US" altLang="ko-KR" sz="1000">
+                <a:solidFill>
+                  <a:srgbClr val="CF8E6D"/>
+                </a:solidFill>
+                <a:effectLst/>
+                <a:latin typeface="JetBrains Mono"/>
+              </a:rPr>
+              <a:t>redpanda</a:t>
+            </a:r>
+            <a:r>
+              <a:rPr lang="en-US" altLang="ko-KR" sz="1000">
+                <a:solidFill>
+                  <a:srgbClr val="BCBEC4"/>
+                </a:solidFill>
+                <a:effectLst/>
+                <a:latin typeface="JetBrains Mono"/>
+              </a:rPr>
+              <a:t>:</a:t>
+            </a:r>
+            <a:br>
+              <a:rPr lang="en-US" altLang="ko-KR" sz="1000">
+                <a:solidFill>
+                  <a:srgbClr val="BCBEC4"/>
+                </a:solidFill>
+                <a:effectLst/>
+                <a:latin typeface="JetBrains Mono"/>
+              </a:rPr>
+            </a:br>
+            <a:r>
+              <a:rPr lang="en-US" altLang="ko-KR" sz="1000">
+                <a:solidFill>
+                  <a:srgbClr val="BCBEC4"/>
+                </a:solidFill>
+                <a:effectLst/>
+                <a:latin typeface="JetBrains Mono"/>
+              </a:rPr>
+              <a:t>        </a:t>
+            </a:r>
+            <a:r>
+              <a:rPr lang="en-US" altLang="ko-KR" sz="1000">
+                <a:solidFill>
+                  <a:srgbClr val="CF8E6D"/>
+                </a:solidFill>
+                <a:effectLst/>
+                <a:latin typeface="JetBrains Mono"/>
+              </a:rPr>
+              <a:t>condition</a:t>
+            </a:r>
+            <a:r>
+              <a:rPr lang="en-US" altLang="ko-KR" sz="1000">
+                <a:solidFill>
+                  <a:srgbClr val="BCBEC4"/>
+                </a:solidFill>
+                <a:effectLst/>
+                <a:latin typeface="JetBrains Mono"/>
+              </a:rPr>
+              <a:t>: service_healthy  </a:t>
+            </a:r>
+            <a:r>
+              <a:rPr lang="en-US" altLang="ko-KR" sz="1000" i="1">
+                <a:solidFill>
+                  <a:srgbClr val="5F826B"/>
+                </a:solidFill>
+                <a:effectLst/>
+                <a:latin typeface="JetBrains Mono"/>
+              </a:rPr>
+              <a:t># </a:t>
+            </a:r>
+            <a:r>
+              <a:rPr lang="ko-KR" altLang="en-US" sz="1000" i="1">
+                <a:solidFill>
+                  <a:srgbClr val="5F826B"/>
+                </a:solidFill>
+                <a:effectLst/>
+                <a:latin typeface="Courier New" panose="02070309020205020404" pitchFamily="49" charset="0"/>
+              </a:rPr>
+              <a:t>✅</a:t>
+            </a:r>
+            <a:r>
+              <a:rPr lang="ko-KR" altLang="en-US" sz="1000" i="1">
+                <a:solidFill>
+                  <a:srgbClr val="5F826B"/>
+                </a:solidFill>
+                <a:effectLst/>
+                <a:latin typeface="JetBrains Mono"/>
+              </a:rPr>
+              <a:t> </a:t>
+            </a:r>
+            <a:r>
+              <a:rPr lang="en-US" altLang="ko-KR" sz="1000" i="1">
+                <a:solidFill>
+                  <a:srgbClr val="5F826B"/>
+                </a:solidFill>
+                <a:effectLst/>
+                <a:latin typeface="JetBrains Mono"/>
+              </a:rPr>
+              <a:t>"</a:t>
+            </a:r>
+            <a:r>
+              <a:rPr lang="ko-KR" altLang="en-US" sz="1000" i="1">
+                <a:solidFill>
+                  <a:srgbClr val="5F826B"/>
+                </a:solidFill>
+                <a:effectLst/>
+                <a:latin typeface="Courier New" panose="02070309020205020404" pitchFamily="49" charset="0"/>
+              </a:rPr>
+              <a:t>실행 순서</a:t>
+            </a:r>
+            <a:r>
+              <a:rPr lang="en-US" altLang="ko-KR" sz="1000" i="1">
+                <a:solidFill>
+                  <a:srgbClr val="5F826B"/>
+                </a:solidFill>
+                <a:effectLst/>
+                <a:latin typeface="JetBrains Mono"/>
+              </a:rPr>
+              <a:t>"</a:t>
+            </a:r>
+            <a:r>
+              <a:rPr lang="ko-KR" altLang="en-US" sz="1000" i="1">
+                <a:solidFill>
+                  <a:srgbClr val="5F826B"/>
+                </a:solidFill>
+                <a:effectLst/>
+                <a:latin typeface="Courier New" panose="02070309020205020404" pitchFamily="49" charset="0"/>
+              </a:rPr>
+              <a:t>가 아니라</a:t>
+            </a:r>
+            <a:r>
+              <a:rPr lang="ko-KR" altLang="en-US" sz="1000" i="1">
+                <a:solidFill>
+                  <a:srgbClr val="5F826B"/>
+                </a:solidFill>
+                <a:effectLst/>
+                <a:latin typeface="JetBrains Mono"/>
+              </a:rPr>
+              <a:t> </a:t>
+            </a:r>
+            <a:r>
+              <a:rPr lang="en-US" altLang="ko-KR" sz="1000" i="1">
+                <a:solidFill>
+                  <a:srgbClr val="5F826B"/>
+                </a:solidFill>
+                <a:effectLst/>
+                <a:latin typeface="JetBrains Mono"/>
+              </a:rPr>
+              <a:t>"</a:t>
+            </a:r>
+            <a:r>
+              <a:rPr lang="ko-KR" altLang="en-US" sz="1000" i="1">
+                <a:solidFill>
+                  <a:srgbClr val="5F826B"/>
+                </a:solidFill>
+                <a:effectLst/>
+                <a:latin typeface="Courier New" panose="02070309020205020404" pitchFamily="49" charset="0"/>
+              </a:rPr>
+              <a:t>준비 완료</a:t>
+            </a:r>
+            <a:r>
+              <a:rPr lang="en-US" altLang="ko-KR" sz="1000" i="1">
+                <a:solidFill>
+                  <a:srgbClr val="5F826B"/>
+                </a:solidFill>
+                <a:effectLst/>
+                <a:latin typeface="JetBrains Mono"/>
+              </a:rPr>
+              <a:t>"</a:t>
+            </a:r>
+            <a:r>
+              <a:rPr lang="ko-KR" altLang="en-US" sz="1000" i="1">
+                <a:solidFill>
+                  <a:srgbClr val="5F826B"/>
+                </a:solidFill>
+                <a:effectLst/>
+                <a:latin typeface="Courier New" panose="02070309020205020404" pitchFamily="49" charset="0"/>
+              </a:rPr>
+              <a:t>를 보장</a:t>
+            </a:r>
+            <a:br>
+              <a:rPr lang="ko-KR" altLang="en-US" sz="1000" i="1">
+                <a:solidFill>
+                  <a:srgbClr val="5F826B"/>
+                </a:solidFill>
+                <a:effectLst/>
+                <a:latin typeface="Courier New" panose="02070309020205020404" pitchFamily="49" charset="0"/>
+              </a:rPr>
+            </a:br>
+            <a:br>
+              <a:rPr lang="ko-KR" altLang="en-US" sz="1000" i="1">
+                <a:solidFill>
+                  <a:srgbClr val="5F826B"/>
+                </a:solidFill>
+                <a:effectLst/>
+                <a:latin typeface="Courier New" panose="02070309020205020404" pitchFamily="49" charset="0"/>
+              </a:rPr>
+            </a:br>
+            <a:r>
+              <a:rPr lang="en-US" altLang="ko-KR" sz="1000">
+                <a:solidFill>
+                  <a:srgbClr val="CF8E6D"/>
+                </a:solidFill>
+                <a:effectLst/>
+                <a:latin typeface="JetBrains Mono"/>
+              </a:rPr>
+              <a:t>volumes</a:t>
+            </a:r>
+            <a:r>
+              <a:rPr lang="en-US" altLang="ko-KR" sz="1000">
+                <a:solidFill>
+                  <a:srgbClr val="BCBEC4"/>
+                </a:solidFill>
+                <a:effectLst/>
+                <a:latin typeface="JetBrains Mono"/>
+              </a:rPr>
+              <a:t>:</a:t>
+            </a:r>
+            <a:br>
+              <a:rPr lang="en-US" altLang="ko-KR" sz="1000">
+                <a:solidFill>
+                  <a:srgbClr val="BCBEC4"/>
+                </a:solidFill>
+                <a:effectLst/>
+                <a:latin typeface="JetBrains Mono"/>
+              </a:rPr>
+            </a:br>
+            <a:r>
+              <a:rPr lang="en-US" altLang="ko-KR" sz="1000">
+                <a:solidFill>
+                  <a:srgbClr val="BCBEC4"/>
+                </a:solidFill>
+                <a:effectLst/>
+                <a:latin typeface="JetBrains Mono"/>
+              </a:rPr>
+              <a:t>  </a:t>
+            </a:r>
+            <a:r>
+              <a:rPr lang="en-US" altLang="ko-KR" sz="1000">
+                <a:solidFill>
+                  <a:srgbClr val="CF8E6D"/>
+                </a:solidFill>
+                <a:effectLst/>
+                <a:latin typeface="JetBrains Mono"/>
+              </a:rPr>
+              <a:t>redpanda_data</a:t>
+            </a:r>
+            <a:r>
+              <a:rPr lang="en-US" altLang="ko-KR" sz="1000">
+                <a:solidFill>
+                  <a:srgbClr val="BCBEC4"/>
+                </a:solidFill>
+                <a:effectLst/>
+                <a:latin typeface="JetBrains Mono"/>
+              </a:rPr>
+              <a:t>:</a:t>
+            </a:r>
+          </a:p>
+        </p:txBody>
+      </p:sp>
+      <p:sp>
+        <p:nvSpPr>
+          <p:cNvPr id="17" name="TextBox 16">
+            <a:extLst>
+              <a:ext uri="{FF2B5EF4-FFF2-40B4-BE49-F238E27FC236}">
+                <a16:creationId xmlns:a16="http://schemas.microsoft.com/office/drawing/2014/main" id="{FE6F803C-69F1-EF97-C815-63BD65F93387}"/>
+              </a:ext>
+            </a:extLst>
+          </p:cNvPr>
+          <p:cNvSpPr txBox="1"/>
+          <p:nvPr/>
+        </p:nvSpPr>
+        <p:spPr>
+          <a:xfrm>
+            <a:off x="219777" y="393327"/>
+            <a:ext cx="5622758" cy="5424562"/>
+          </a:xfrm>
+          <a:prstGeom prst="rect">
+            <a:avLst/>
+          </a:prstGeom>
+          <a:solidFill>
+            <a:schemeClr val="tx1"/>
+          </a:solidFill>
+        </p:spPr>
+        <p:txBody>
+          <a:bodyPr wrap="square">
+            <a:spAutoFit/>
+          </a:bodyPr>
+          <a:lstStyle/>
+          <a:p>
+            <a:r>
+              <a:rPr lang="en-US" altLang="ko-KR" sz="1050">
+                <a:solidFill>
+                  <a:srgbClr val="CF8E6D"/>
+                </a:solidFill>
+                <a:effectLst/>
+                <a:latin typeface="JetBrains Mono"/>
+              </a:rPr>
+              <a:t>services</a:t>
+            </a:r>
+            <a:r>
+              <a:rPr lang="en-US" altLang="ko-KR" sz="1050">
+                <a:solidFill>
+                  <a:srgbClr val="BCBEC4"/>
+                </a:solidFill>
+                <a:effectLst/>
+                <a:latin typeface="JetBrains Mono"/>
+              </a:rPr>
+              <a:t>:</a:t>
+            </a:r>
+            <a:br>
+              <a:rPr lang="en-US" altLang="ko-KR" sz="1050">
+                <a:solidFill>
+                  <a:srgbClr val="BCBEC4"/>
+                </a:solidFill>
+                <a:effectLst/>
+                <a:latin typeface="JetBrains Mono"/>
+              </a:rPr>
+            </a:br>
+            <a:r>
+              <a:rPr lang="en-US" altLang="ko-KR" sz="1050">
+                <a:solidFill>
+                  <a:srgbClr val="BCBEC4"/>
+                </a:solidFill>
+                <a:effectLst/>
+                <a:latin typeface="JetBrains Mono"/>
+              </a:rPr>
+              <a:t>  </a:t>
+            </a:r>
+            <a:r>
+              <a:rPr lang="en-US" altLang="ko-KR" sz="1050">
+                <a:solidFill>
+                  <a:srgbClr val="CF8E6D"/>
+                </a:solidFill>
+                <a:effectLst/>
+                <a:latin typeface="JetBrains Mono"/>
+              </a:rPr>
+              <a:t>redpanda</a:t>
+            </a:r>
+            <a:r>
+              <a:rPr lang="en-US" altLang="ko-KR" sz="1050">
+                <a:solidFill>
+                  <a:srgbClr val="BCBEC4"/>
+                </a:solidFill>
+                <a:effectLst/>
+                <a:latin typeface="JetBrains Mono"/>
+              </a:rPr>
+              <a:t>:</a:t>
+            </a:r>
+            <a:br>
+              <a:rPr lang="en-US" altLang="ko-KR" sz="1050">
+                <a:solidFill>
+                  <a:srgbClr val="BCBEC4"/>
+                </a:solidFill>
+                <a:effectLst/>
+                <a:latin typeface="JetBrains Mono"/>
+              </a:rPr>
+            </a:br>
+            <a:r>
+              <a:rPr lang="en-US" altLang="ko-KR" sz="1050">
+                <a:solidFill>
+                  <a:srgbClr val="BCBEC4"/>
+                </a:solidFill>
+                <a:effectLst/>
+                <a:latin typeface="JetBrains Mono"/>
+              </a:rPr>
+              <a:t>    </a:t>
+            </a:r>
+            <a:r>
+              <a:rPr lang="en-US" altLang="ko-KR" sz="1050">
+                <a:solidFill>
+                  <a:srgbClr val="CF8E6D"/>
+                </a:solidFill>
+                <a:effectLst/>
+                <a:latin typeface="JetBrains Mono"/>
+              </a:rPr>
+              <a:t>image</a:t>
+            </a:r>
+            <a:r>
+              <a:rPr lang="en-US" altLang="ko-KR" sz="1050">
+                <a:solidFill>
+                  <a:srgbClr val="BCBEC4"/>
+                </a:solidFill>
+                <a:effectLst/>
+                <a:latin typeface="JetBrains Mono"/>
+              </a:rPr>
+              <a:t>: docker.redpanda.com/redpandadata/redpanda:latest</a:t>
+            </a:r>
+            <a:br>
+              <a:rPr lang="en-US" altLang="ko-KR" sz="1050">
+                <a:solidFill>
+                  <a:srgbClr val="BCBEC4"/>
+                </a:solidFill>
+                <a:effectLst/>
+                <a:latin typeface="JetBrains Mono"/>
+              </a:rPr>
+            </a:br>
+            <a:r>
+              <a:rPr lang="en-US" altLang="ko-KR" sz="1050">
+                <a:solidFill>
+                  <a:srgbClr val="BCBEC4"/>
+                </a:solidFill>
+                <a:effectLst/>
+                <a:latin typeface="JetBrains Mono"/>
+              </a:rPr>
+              <a:t>    </a:t>
+            </a:r>
+            <a:r>
+              <a:rPr lang="en-US" altLang="ko-KR" sz="1050">
+                <a:solidFill>
+                  <a:srgbClr val="CF8E6D"/>
+                </a:solidFill>
+                <a:effectLst/>
+                <a:latin typeface="JetBrains Mono"/>
+              </a:rPr>
+              <a:t>command</a:t>
+            </a:r>
+            <a:r>
+              <a:rPr lang="en-US" altLang="ko-KR" sz="1050">
+                <a:solidFill>
+                  <a:srgbClr val="BCBEC4"/>
+                </a:solidFill>
+                <a:effectLst/>
+                <a:latin typeface="JetBrains Mono"/>
+              </a:rPr>
+              <a:t>:</a:t>
+            </a:r>
+            <a:br>
+              <a:rPr lang="en-US" altLang="ko-KR" sz="1050">
+                <a:solidFill>
+                  <a:srgbClr val="BCBEC4"/>
+                </a:solidFill>
+                <a:effectLst/>
+                <a:latin typeface="JetBrains Mono"/>
+              </a:rPr>
+            </a:br>
+            <a:r>
+              <a:rPr lang="en-US" altLang="ko-KR" sz="1050">
+                <a:solidFill>
+                  <a:srgbClr val="BCBEC4"/>
+                </a:solidFill>
+                <a:effectLst/>
+                <a:latin typeface="JetBrains Mono"/>
+              </a:rPr>
+              <a:t>      - redpanda</a:t>
+            </a:r>
+            <a:br>
+              <a:rPr lang="en-US" altLang="ko-KR" sz="1050">
+                <a:solidFill>
+                  <a:srgbClr val="BCBEC4"/>
+                </a:solidFill>
+                <a:effectLst/>
+                <a:latin typeface="JetBrains Mono"/>
+              </a:rPr>
+            </a:br>
+            <a:r>
+              <a:rPr lang="en-US" altLang="ko-KR" sz="1050">
+                <a:solidFill>
+                  <a:srgbClr val="BCBEC4"/>
+                </a:solidFill>
+                <a:effectLst/>
+                <a:latin typeface="JetBrains Mono"/>
+              </a:rPr>
+              <a:t>      - start</a:t>
+            </a:r>
+            <a:br>
+              <a:rPr lang="en-US" altLang="ko-KR" sz="1050">
+                <a:solidFill>
+                  <a:srgbClr val="BCBEC4"/>
+                </a:solidFill>
+                <a:effectLst/>
+                <a:latin typeface="JetBrains Mono"/>
+              </a:rPr>
+            </a:br>
+            <a:r>
+              <a:rPr lang="en-US" altLang="ko-KR" sz="1050">
+                <a:solidFill>
+                  <a:srgbClr val="BCBEC4"/>
+                </a:solidFill>
+                <a:effectLst/>
+                <a:latin typeface="JetBrains Mono"/>
+              </a:rPr>
+              <a:t>      - --mode</a:t>
+            </a:r>
+            <a:br>
+              <a:rPr lang="en-US" altLang="ko-KR" sz="1050">
+                <a:solidFill>
+                  <a:srgbClr val="BCBEC4"/>
+                </a:solidFill>
+                <a:effectLst/>
+                <a:latin typeface="JetBrains Mono"/>
+              </a:rPr>
+            </a:br>
+            <a:r>
+              <a:rPr lang="en-US" altLang="ko-KR" sz="1050">
+                <a:solidFill>
+                  <a:srgbClr val="BCBEC4"/>
+                </a:solidFill>
+                <a:effectLst/>
+                <a:latin typeface="JetBrains Mono"/>
+              </a:rPr>
+              <a:t>      - dev-container</a:t>
+            </a:r>
+            <a:br>
+              <a:rPr lang="en-US" altLang="ko-KR" sz="1050">
+                <a:solidFill>
+                  <a:srgbClr val="BCBEC4"/>
+                </a:solidFill>
+                <a:effectLst/>
+                <a:latin typeface="JetBrains Mono"/>
+              </a:rPr>
+            </a:br>
+            <a:br>
+              <a:rPr lang="en-US" altLang="ko-KR" sz="1050">
+                <a:solidFill>
+                  <a:srgbClr val="BCBEC4"/>
+                </a:solidFill>
+                <a:effectLst/>
+                <a:latin typeface="JetBrains Mono"/>
+              </a:rPr>
+            </a:br>
+            <a:r>
+              <a:rPr lang="en-US" altLang="ko-KR" sz="1050">
+                <a:solidFill>
+                  <a:srgbClr val="BCBEC4"/>
+                </a:solidFill>
+                <a:effectLst/>
+                <a:latin typeface="JetBrains Mono"/>
+              </a:rPr>
+              <a:t>      </a:t>
+            </a:r>
+            <a:r>
+              <a:rPr lang="en-US" altLang="ko-KR" sz="1050" i="1">
+                <a:solidFill>
+                  <a:srgbClr val="5F826B"/>
+                </a:solidFill>
+                <a:effectLst/>
+                <a:latin typeface="JetBrains Mono"/>
+              </a:rPr>
+              <a:t># </a:t>
+            </a:r>
+            <a:r>
+              <a:rPr lang="ko-KR" altLang="en-US" sz="1050" i="1">
+                <a:solidFill>
+                  <a:srgbClr val="5F826B"/>
+                </a:solidFill>
+                <a:effectLst/>
+                <a:latin typeface="Courier New" panose="02070309020205020404" pitchFamily="49" charset="0"/>
+              </a:rPr>
+              <a:t>✅ 내부</a:t>
+            </a:r>
+            <a:r>
+              <a:rPr lang="en-US" altLang="ko-KR" sz="1050" i="1">
+                <a:solidFill>
+                  <a:srgbClr val="5F826B"/>
+                </a:solidFill>
+                <a:effectLst/>
+                <a:latin typeface="JetBrains Mono"/>
+              </a:rPr>
+              <a:t>/</a:t>
+            </a:r>
+            <a:r>
+              <a:rPr lang="ko-KR" altLang="en-US" sz="1050" i="1">
+                <a:solidFill>
+                  <a:srgbClr val="5F826B"/>
+                </a:solidFill>
+                <a:effectLst/>
+                <a:latin typeface="Courier New" panose="02070309020205020404" pitchFamily="49" charset="0"/>
+              </a:rPr>
+              <a:t>외부 리스너 분리</a:t>
+            </a:r>
+            <a:r>
+              <a:rPr lang="en-US" altLang="ko-KR" sz="1050" i="1">
+                <a:solidFill>
+                  <a:srgbClr val="5F826B"/>
+                </a:solidFill>
+                <a:effectLst/>
+                <a:latin typeface="JetBrains Mono"/>
+              </a:rPr>
+              <a:t>: </a:t>
+            </a:r>
+            <a:r>
+              <a:rPr lang="ko-KR" altLang="en-US" sz="1050" i="1">
+                <a:solidFill>
+                  <a:srgbClr val="5F826B"/>
+                </a:solidFill>
+                <a:effectLst/>
+                <a:latin typeface="Courier New" panose="02070309020205020404" pitchFamily="49" charset="0"/>
+              </a:rPr>
+              <a:t>컨테이너 내부는</a:t>
+            </a:r>
+            <a:r>
+              <a:rPr lang="ko-KR" altLang="en-US" sz="1050" i="1">
+                <a:solidFill>
+                  <a:srgbClr val="5F826B"/>
+                </a:solidFill>
+                <a:effectLst/>
+                <a:latin typeface="JetBrains Mono"/>
+              </a:rPr>
+              <a:t> </a:t>
+            </a:r>
+            <a:r>
+              <a:rPr lang="en-US" altLang="ko-KR" sz="1050" i="1">
+                <a:solidFill>
+                  <a:srgbClr val="5F826B"/>
+                </a:solidFill>
+                <a:effectLst/>
+                <a:latin typeface="JetBrains Mono"/>
+              </a:rPr>
+              <a:t>9092, </a:t>
+            </a:r>
+            <a:r>
+              <a:rPr lang="ko-KR" altLang="en-US" sz="1050" i="1">
+                <a:solidFill>
+                  <a:srgbClr val="5F826B"/>
+                </a:solidFill>
+                <a:effectLst/>
+                <a:latin typeface="Courier New" panose="02070309020205020404" pitchFamily="49" charset="0"/>
+              </a:rPr>
+              <a:t>호스트는</a:t>
+            </a:r>
+            <a:r>
+              <a:rPr lang="ko-KR" altLang="en-US" sz="1050" i="1">
+                <a:solidFill>
+                  <a:srgbClr val="5F826B"/>
+                </a:solidFill>
+                <a:effectLst/>
+                <a:latin typeface="JetBrains Mono"/>
+              </a:rPr>
+              <a:t> </a:t>
+            </a:r>
+            <a:r>
+              <a:rPr lang="en-US" altLang="ko-KR" sz="1050" i="1">
+                <a:solidFill>
+                  <a:srgbClr val="5F826B"/>
+                </a:solidFill>
+                <a:effectLst/>
+                <a:latin typeface="JetBrains Mono"/>
+              </a:rPr>
+              <a:t>19092</a:t>
+            </a:r>
+            <a:br>
+              <a:rPr lang="en-US" altLang="ko-KR" sz="1050" i="1">
+                <a:solidFill>
+                  <a:srgbClr val="5F826B"/>
+                </a:solidFill>
+                <a:effectLst/>
+                <a:latin typeface="JetBrains Mono"/>
+              </a:rPr>
+            </a:br>
+            <a:r>
+              <a:rPr lang="en-US" altLang="ko-KR" sz="1050" i="1">
+                <a:solidFill>
+                  <a:srgbClr val="5F826B"/>
+                </a:solidFill>
+                <a:effectLst/>
+                <a:latin typeface="JetBrains Mono"/>
+              </a:rPr>
+              <a:t>      </a:t>
+            </a:r>
+            <a:r>
+              <a:rPr lang="en-US" altLang="ko-KR" sz="1050">
+                <a:solidFill>
+                  <a:srgbClr val="BCBEC4"/>
+                </a:solidFill>
+                <a:effectLst/>
+                <a:latin typeface="JetBrains Mono"/>
+              </a:rPr>
+              <a:t>- --kafka-addr</a:t>
+            </a:r>
+            <a:br>
+              <a:rPr lang="en-US" altLang="ko-KR" sz="1050">
+                <a:solidFill>
+                  <a:srgbClr val="BCBEC4"/>
+                </a:solidFill>
+                <a:effectLst/>
+                <a:latin typeface="JetBrains Mono"/>
+              </a:rPr>
+            </a:br>
+            <a:r>
+              <a:rPr lang="en-US" altLang="ko-KR" sz="1050">
+                <a:solidFill>
+                  <a:srgbClr val="BCBEC4"/>
+                </a:solidFill>
+                <a:effectLst/>
+                <a:latin typeface="JetBrains Mono"/>
+              </a:rPr>
+              <a:t>      - internal://0.0.0.0:9092,external://0.0.0.0:19092</a:t>
+            </a:r>
+            <a:br>
+              <a:rPr lang="en-US" altLang="ko-KR" sz="1050">
+                <a:solidFill>
+                  <a:srgbClr val="BCBEC4"/>
+                </a:solidFill>
+                <a:effectLst/>
+                <a:latin typeface="JetBrains Mono"/>
+              </a:rPr>
+            </a:br>
+            <a:br>
+              <a:rPr lang="en-US" altLang="ko-KR" sz="1050">
+                <a:solidFill>
+                  <a:srgbClr val="BCBEC4"/>
+                </a:solidFill>
+                <a:effectLst/>
+                <a:latin typeface="JetBrains Mono"/>
+              </a:rPr>
+            </a:br>
+            <a:r>
+              <a:rPr lang="en-US" altLang="ko-KR" sz="1050">
+                <a:solidFill>
+                  <a:srgbClr val="BCBEC4"/>
+                </a:solidFill>
+                <a:effectLst/>
+                <a:latin typeface="JetBrains Mono"/>
+              </a:rPr>
+              <a:t>      </a:t>
+            </a:r>
+            <a:r>
+              <a:rPr lang="en-US" altLang="ko-KR" sz="1050" i="1">
+                <a:solidFill>
+                  <a:srgbClr val="5F826B"/>
+                </a:solidFill>
+                <a:effectLst/>
+                <a:latin typeface="JetBrains Mono"/>
+              </a:rPr>
+              <a:t># </a:t>
+            </a:r>
+            <a:r>
+              <a:rPr lang="ko-KR" altLang="en-US" sz="1050" i="1">
+                <a:solidFill>
+                  <a:srgbClr val="5F826B"/>
+                </a:solidFill>
+                <a:effectLst/>
+                <a:latin typeface="Courier New" panose="02070309020205020404" pitchFamily="49" charset="0"/>
+              </a:rPr>
+              <a:t>✅ 광고 주소</a:t>
+            </a:r>
+            <a:r>
+              <a:rPr lang="en-US" altLang="ko-KR" sz="1050" i="1">
+                <a:solidFill>
+                  <a:srgbClr val="5F826B"/>
+                </a:solidFill>
+                <a:effectLst/>
+                <a:latin typeface="JetBrains Mono"/>
+              </a:rPr>
+              <a:t>: </a:t>
+            </a:r>
+            <a:r>
+              <a:rPr lang="ko-KR" altLang="en-US" sz="1050" i="1">
+                <a:solidFill>
+                  <a:srgbClr val="5F826B"/>
+                </a:solidFill>
+                <a:effectLst/>
+                <a:latin typeface="Courier New" panose="02070309020205020404" pitchFamily="49" charset="0"/>
+              </a:rPr>
+              <a:t>내부 클라이언트는</a:t>
+            </a:r>
+            <a:r>
+              <a:rPr lang="ko-KR" altLang="en-US" sz="1050" i="1">
+                <a:solidFill>
+                  <a:srgbClr val="5F826B"/>
+                </a:solidFill>
+                <a:effectLst/>
+                <a:latin typeface="JetBrains Mono"/>
+              </a:rPr>
+              <a:t> </a:t>
+            </a:r>
+            <a:r>
+              <a:rPr lang="en-US" altLang="ko-KR" sz="1050" i="1">
+                <a:solidFill>
+                  <a:srgbClr val="5F826B"/>
+                </a:solidFill>
+                <a:effectLst/>
+                <a:latin typeface="JetBrains Mono"/>
+              </a:rPr>
+              <a:t>redpanda:9092 / </a:t>
+            </a:r>
+            <a:r>
+              <a:rPr lang="ko-KR" altLang="en-US" sz="1050" i="1">
+                <a:solidFill>
+                  <a:srgbClr val="5F826B"/>
+                </a:solidFill>
+                <a:effectLst/>
+                <a:latin typeface="Courier New" panose="02070309020205020404" pitchFamily="49" charset="0"/>
+              </a:rPr>
+              <a:t>호스트는</a:t>
+            </a:r>
+            <a:r>
+              <a:rPr lang="ko-KR" altLang="en-US" sz="1050" i="1">
+                <a:solidFill>
+                  <a:srgbClr val="5F826B"/>
+                </a:solidFill>
+                <a:effectLst/>
+                <a:latin typeface="JetBrains Mono"/>
+              </a:rPr>
+              <a:t> </a:t>
+            </a:r>
+            <a:r>
+              <a:rPr lang="en-US" altLang="ko-KR" sz="1050" i="1">
+                <a:solidFill>
+                  <a:srgbClr val="5F826B"/>
+                </a:solidFill>
+                <a:effectLst/>
+                <a:latin typeface="JetBrains Mono"/>
+              </a:rPr>
+              <a:t>localhost:19092</a:t>
+            </a:r>
+            <a:br>
+              <a:rPr lang="en-US" altLang="ko-KR" sz="1050" i="1">
+                <a:solidFill>
+                  <a:srgbClr val="5F826B"/>
+                </a:solidFill>
+                <a:effectLst/>
+                <a:latin typeface="JetBrains Mono"/>
+              </a:rPr>
+            </a:br>
+            <a:r>
+              <a:rPr lang="en-US" altLang="ko-KR" sz="1050" i="1">
+                <a:solidFill>
+                  <a:srgbClr val="5F826B"/>
+                </a:solidFill>
+                <a:effectLst/>
+                <a:latin typeface="JetBrains Mono"/>
+              </a:rPr>
+              <a:t>      </a:t>
+            </a:r>
+            <a:r>
+              <a:rPr lang="en-US" altLang="ko-KR" sz="1050">
+                <a:solidFill>
+                  <a:srgbClr val="BCBEC4"/>
+                </a:solidFill>
+                <a:effectLst/>
+                <a:latin typeface="JetBrains Mono"/>
+              </a:rPr>
+              <a:t>- --advertise-kafka-addr</a:t>
+            </a:r>
+            <a:br>
+              <a:rPr lang="en-US" altLang="ko-KR" sz="1050">
+                <a:solidFill>
+                  <a:srgbClr val="BCBEC4"/>
+                </a:solidFill>
+                <a:effectLst/>
+                <a:latin typeface="JetBrains Mono"/>
+              </a:rPr>
+            </a:br>
+            <a:r>
+              <a:rPr lang="en-US" altLang="ko-KR" sz="1050">
+                <a:solidFill>
+                  <a:srgbClr val="BCBEC4"/>
+                </a:solidFill>
+                <a:effectLst/>
+                <a:latin typeface="JetBrains Mono"/>
+              </a:rPr>
+              <a:t>      - internal://redpanda:9092,external://localhost:19092</a:t>
+            </a:r>
+            <a:br>
+              <a:rPr lang="en-US" altLang="ko-KR" sz="1050">
+                <a:solidFill>
+                  <a:srgbClr val="BCBEC4"/>
+                </a:solidFill>
+                <a:effectLst/>
+                <a:latin typeface="JetBrains Mono"/>
+              </a:rPr>
+            </a:br>
+            <a:br>
+              <a:rPr lang="en-US" altLang="ko-KR" sz="1050">
+                <a:solidFill>
+                  <a:srgbClr val="BCBEC4"/>
+                </a:solidFill>
+                <a:effectLst/>
+                <a:latin typeface="JetBrains Mono"/>
+              </a:rPr>
+            </a:br>
+            <a:r>
+              <a:rPr lang="en-US" altLang="ko-KR" sz="1050">
+                <a:solidFill>
+                  <a:srgbClr val="BCBEC4"/>
+                </a:solidFill>
+                <a:effectLst/>
+                <a:latin typeface="JetBrains Mono"/>
+              </a:rPr>
+              <a:t>      </a:t>
+            </a:r>
+            <a:r>
+              <a:rPr lang="en-US" altLang="ko-KR" sz="1050" i="1">
+                <a:solidFill>
+                  <a:srgbClr val="5F826B"/>
+                </a:solidFill>
+                <a:effectLst/>
+                <a:latin typeface="JetBrains Mono"/>
+              </a:rPr>
+              <a:t># (</a:t>
+            </a:r>
+            <a:r>
+              <a:rPr lang="ko-KR" altLang="en-US" sz="1050" i="1">
+                <a:solidFill>
+                  <a:srgbClr val="5F826B"/>
+                </a:solidFill>
+                <a:effectLst/>
+                <a:latin typeface="Courier New" panose="02070309020205020404" pitchFamily="49" charset="0"/>
+              </a:rPr>
+              <a:t>선택</a:t>
+            </a:r>
+            <a:r>
+              <a:rPr lang="en-US" altLang="ko-KR" sz="1050" i="1">
+                <a:solidFill>
+                  <a:srgbClr val="5F826B"/>
+                </a:solidFill>
+                <a:effectLst/>
+                <a:latin typeface="JetBrains Mono"/>
+              </a:rPr>
+              <a:t>) </a:t>
+            </a:r>
+            <a:r>
+              <a:rPr lang="ko-KR" altLang="en-US" sz="1050" i="1">
+                <a:solidFill>
+                  <a:srgbClr val="5F826B"/>
+                </a:solidFill>
+                <a:effectLst/>
+                <a:latin typeface="Courier New" panose="02070309020205020404" pitchFamily="49" charset="0"/>
+              </a:rPr>
+              <a:t>개발환경에서 리소스 과소</a:t>
+            </a:r>
+            <a:r>
+              <a:rPr lang="en-US" altLang="ko-KR" sz="1050" i="1">
+                <a:solidFill>
+                  <a:srgbClr val="5F826B"/>
+                </a:solidFill>
+                <a:effectLst/>
+                <a:latin typeface="JetBrains Mono"/>
+              </a:rPr>
+              <a:t>/</a:t>
+            </a:r>
+            <a:r>
+              <a:rPr lang="ko-KR" altLang="en-US" sz="1050" i="1">
+                <a:solidFill>
+                  <a:srgbClr val="5F826B"/>
+                </a:solidFill>
+                <a:effectLst/>
+                <a:latin typeface="Courier New" panose="02070309020205020404" pitchFamily="49" charset="0"/>
+              </a:rPr>
+              <a:t>과다를 피하고 싶으면 튜닝 옵션 추가 가능</a:t>
+            </a:r>
+            <a:br>
+              <a:rPr lang="ko-KR" altLang="en-US" sz="1050" i="1">
+                <a:solidFill>
+                  <a:srgbClr val="5F826B"/>
+                </a:solidFill>
+                <a:effectLst/>
+                <a:latin typeface="Courier New" panose="02070309020205020404" pitchFamily="49" charset="0"/>
+              </a:rPr>
+            </a:br>
+            <a:r>
+              <a:rPr lang="ko-KR" altLang="en-US" sz="1050" i="1">
+                <a:solidFill>
+                  <a:srgbClr val="5F826B"/>
+                </a:solidFill>
+                <a:effectLst/>
+                <a:latin typeface="Courier New" panose="02070309020205020404" pitchFamily="49" charset="0"/>
+              </a:rPr>
+              <a:t>      </a:t>
+            </a:r>
+            <a:r>
+              <a:rPr lang="en-US" altLang="ko-KR" sz="1050" i="1">
+                <a:solidFill>
+                  <a:srgbClr val="5F826B"/>
+                </a:solidFill>
+                <a:effectLst/>
+                <a:latin typeface="JetBrains Mono"/>
+              </a:rPr>
+              <a:t># - --smp</a:t>
+            </a:r>
+            <a:br>
+              <a:rPr lang="en-US" altLang="ko-KR" sz="1050" i="1">
+                <a:solidFill>
+                  <a:srgbClr val="5F826B"/>
+                </a:solidFill>
+                <a:effectLst/>
+                <a:latin typeface="JetBrains Mono"/>
+              </a:rPr>
+            </a:br>
+            <a:r>
+              <a:rPr lang="en-US" altLang="ko-KR" sz="1050" i="1">
+                <a:solidFill>
+                  <a:srgbClr val="5F826B"/>
+                </a:solidFill>
+                <a:effectLst/>
+                <a:latin typeface="JetBrains Mono"/>
+              </a:rPr>
+              <a:t>      # - "1"</a:t>
+            </a:r>
+            <a:br>
+              <a:rPr lang="en-US" altLang="ko-KR" sz="1050" i="1">
+                <a:solidFill>
+                  <a:srgbClr val="5F826B"/>
+                </a:solidFill>
+                <a:effectLst/>
+                <a:latin typeface="JetBrains Mono"/>
+              </a:rPr>
+            </a:br>
+            <a:r>
+              <a:rPr lang="en-US" altLang="ko-KR" sz="1050" i="1">
+                <a:solidFill>
+                  <a:srgbClr val="5F826B"/>
+                </a:solidFill>
+                <a:effectLst/>
+                <a:latin typeface="JetBrains Mono"/>
+              </a:rPr>
+              <a:t>      # - --memory</a:t>
+            </a:r>
+            <a:br>
+              <a:rPr lang="en-US" altLang="ko-KR" sz="1050" i="1">
+                <a:solidFill>
+                  <a:srgbClr val="5F826B"/>
+                </a:solidFill>
+                <a:effectLst/>
+                <a:latin typeface="JetBrains Mono"/>
+              </a:rPr>
+            </a:br>
+            <a:r>
+              <a:rPr lang="en-US" altLang="ko-KR" sz="1050" i="1">
+                <a:solidFill>
+                  <a:srgbClr val="5F826B"/>
+                </a:solidFill>
+                <a:effectLst/>
+                <a:latin typeface="JetBrains Mono"/>
+              </a:rPr>
+              <a:t>      # - "1G"</a:t>
+            </a:r>
+            <a:br>
+              <a:rPr lang="en-US" altLang="ko-KR" sz="1050" i="1">
+                <a:solidFill>
+                  <a:srgbClr val="5F826B"/>
+                </a:solidFill>
+                <a:effectLst/>
+                <a:latin typeface="JetBrains Mono"/>
+              </a:rPr>
+            </a:br>
+            <a:r>
+              <a:rPr lang="en-US" altLang="ko-KR" sz="1050" i="1">
+                <a:solidFill>
+                  <a:srgbClr val="5F826B"/>
+                </a:solidFill>
+                <a:effectLst/>
+                <a:latin typeface="JetBrains Mono"/>
+              </a:rPr>
+              <a:t>      # - --overprovisioned</a:t>
+            </a:r>
+            <a:br>
+              <a:rPr lang="en-US" altLang="ko-KR" sz="1050" i="1">
+                <a:solidFill>
+                  <a:srgbClr val="5F826B"/>
+                </a:solidFill>
+                <a:effectLst/>
+                <a:latin typeface="JetBrains Mono"/>
+              </a:rPr>
+            </a:br>
+            <a:r>
+              <a:rPr lang="en-US" altLang="ko-KR" sz="1050" i="1">
+                <a:solidFill>
+                  <a:srgbClr val="5F826B"/>
+                </a:solidFill>
+                <a:effectLst/>
+                <a:latin typeface="JetBrains Mono"/>
+              </a:rPr>
+              <a:t>      # - --reserved-memory</a:t>
+            </a:r>
+            <a:br>
+              <a:rPr lang="en-US" altLang="ko-KR" sz="1050" i="1">
+                <a:solidFill>
+                  <a:srgbClr val="5F826B"/>
+                </a:solidFill>
+                <a:effectLst/>
+                <a:latin typeface="JetBrains Mono"/>
+              </a:rPr>
+            </a:br>
+            <a:r>
+              <a:rPr lang="en-US" altLang="ko-KR" sz="1050" i="1">
+                <a:solidFill>
+                  <a:srgbClr val="5F826B"/>
+                </a:solidFill>
+                <a:effectLst/>
+                <a:latin typeface="JetBrains Mono"/>
+              </a:rPr>
+              <a:t>      # - "0M"</a:t>
+            </a:r>
+          </a:p>
+          <a:p>
+            <a:br>
+              <a:rPr lang="en-US" altLang="ko-KR" sz="1050" i="1">
+                <a:solidFill>
+                  <a:srgbClr val="5F826B"/>
+                </a:solidFill>
+                <a:effectLst/>
+                <a:latin typeface="JetBrains Mono"/>
+              </a:rPr>
+            </a:br>
+            <a:r>
+              <a:rPr lang="en-US" altLang="ko-KR" sz="1050">
+                <a:solidFill>
+                  <a:srgbClr val="CF8E6D"/>
+                </a:solidFill>
+                <a:latin typeface="JetBrains Mono"/>
+              </a:rPr>
+              <a:t> ports</a:t>
+            </a:r>
+            <a:r>
+              <a:rPr lang="en-US" altLang="ko-KR" sz="1050">
+                <a:solidFill>
+                  <a:srgbClr val="BCBEC4"/>
+                </a:solidFill>
+                <a:latin typeface="JetBrains Mono"/>
+              </a:rPr>
+              <a:t>:</a:t>
+            </a:r>
+            <a:br>
+              <a:rPr lang="en-US" altLang="ko-KR" sz="1050">
+                <a:solidFill>
+                  <a:srgbClr val="BCBEC4"/>
+                </a:solidFill>
+                <a:latin typeface="JetBrains Mono"/>
+              </a:rPr>
+            </a:br>
+            <a:r>
+              <a:rPr lang="en-US" altLang="ko-KR" sz="1050">
+                <a:solidFill>
+                  <a:srgbClr val="BCBEC4"/>
+                </a:solidFill>
+                <a:latin typeface="JetBrains Mono"/>
+              </a:rPr>
+              <a:t>      - </a:t>
+            </a:r>
+            <a:r>
+              <a:rPr lang="en-US" altLang="ko-KR" sz="1050">
+                <a:solidFill>
+                  <a:srgbClr val="6AAB73"/>
+                </a:solidFill>
+                <a:latin typeface="JetBrains Mono"/>
+              </a:rPr>
+              <a:t>"19092:19092" </a:t>
+            </a:r>
+            <a:r>
+              <a:rPr lang="en-US" altLang="ko-KR" sz="1050" i="1">
+                <a:solidFill>
+                  <a:srgbClr val="5F826B"/>
+                </a:solidFill>
+                <a:latin typeface="JetBrains Mono"/>
+              </a:rPr>
+              <a:t># </a:t>
+            </a:r>
+            <a:r>
+              <a:rPr lang="ko-KR" altLang="en-US" sz="1050" i="1">
+                <a:solidFill>
+                  <a:srgbClr val="5F826B"/>
+                </a:solidFill>
+                <a:latin typeface="Courier New" panose="02070309020205020404" pitchFamily="49" charset="0"/>
+              </a:rPr>
+              <a:t>호스트</a:t>
+            </a:r>
+            <a:r>
+              <a:rPr lang="en-US" altLang="ko-KR" sz="1050" i="1">
+                <a:solidFill>
+                  <a:srgbClr val="5F826B"/>
+                </a:solidFill>
+                <a:latin typeface="JetBrains Mono"/>
+              </a:rPr>
+              <a:t>(</a:t>
+            </a:r>
+            <a:r>
+              <a:rPr lang="ko-KR" altLang="en-US" sz="1050" i="1">
+                <a:solidFill>
+                  <a:srgbClr val="5F826B"/>
+                </a:solidFill>
+                <a:latin typeface="Courier New" panose="02070309020205020404" pitchFamily="49" charset="0"/>
+              </a:rPr>
+              <a:t>스프링 앱</a:t>
+            </a:r>
+            <a:r>
+              <a:rPr lang="en-US" altLang="ko-KR" sz="1050" i="1">
+                <a:solidFill>
+                  <a:srgbClr val="5F826B"/>
+                </a:solidFill>
+                <a:latin typeface="JetBrains Mono"/>
+              </a:rPr>
+              <a:t>) </a:t>
+            </a:r>
+            <a:r>
+              <a:rPr lang="ko-KR" altLang="en-US" sz="1050" i="1">
+                <a:solidFill>
+                  <a:srgbClr val="5F826B"/>
+                </a:solidFill>
+                <a:latin typeface="Courier New" panose="02070309020205020404" pitchFamily="49" charset="0"/>
+              </a:rPr>
+              <a:t>접근용</a:t>
+            </a:r>
+            <a:br>
+              <a:rPr lang="ko-KR" altLang="en-US" sz="1050" i="1">
+                <a:solidFill>
+                  <a:srgbClr val="5F826B"/>
+                </a:solidFill>
+                <a:latin typeface="Courier New" panose="02070309020205020404" pitchFamily="49" charset="0"/>
+              </a:rPr>
+            </a:br>
+            <a:r>
+              <a:rPr lang="ko-KR" altLang="en-US" sz="1050" i="1">
+                <a:solidFill>
+                  <a:srgbClr val="5F826B"/>
+                </a:solidFill>
+                <a:latin typeface="Courier New" panose="02070309020205020404" pitchFamily="49" charset="0"/>
+              </a:rPr>
+              <a:t>      </a:t>
+            </a:r>
+            <a:r>
+              <a:rPr lang="en-US" altLang="ko-KR" sz="1050">
+                <a:solidFill>
+                  <a:srgbClr val="BCBEC4"/>
+                </a:solidFill>
+                <a:latin typeface="JetBrains Mono"/>
+              </a:rPr>
+              <a:t>- </a:t>
+            </a:r>
+            <a:r>
+              <a:rPr lang="en-US" altLang="ko-KR" sz="1050">
+                <a:solidFill>
+                  <a:srgbClr val="6AAB73"/>
+                </a:solidFill>
+                <a:latin typeface="JetBrains Mono"/>
+              </a:rPr>
+              <a:t>"9644:9644"   </a:t>
+            </a:r>
+            <a:r>
+              <a:rPr lang="en-US" altLang="ko-KR" sz="1050" i="1">
+                <a:solidFill>
+                  <a:srgbClr val="5F826B"/>
+                </a:solidFill>
+                <a:latin typeface="JetBrains Mono"/>
+              </a:rPr>
+              <a:t># (</a:t>
+            </a:r>
+            <a:r>
+              <a:rPr lang="ko-KR" altLang="en-US" sz="1050" i="1">
+                <a:solidFill>
+                  <a:srgbClr val="5F826B"/>
+                </a:solidFill>
+                <a:latin typeface="Courier New" panose="02070309020205020404" pitchFamily="49" charset="0"/>
+              </a:rPr>
+              <a:t>선택</a:t>
+            </a:r>
+            <a:r>
+              <a:rPr lang="en-US" altLang="ko-KR" sz="1050" i="1">
+                <a:solidFill>
+                  <a:srgbClr val="5F826B"/>
+                </a:solidFill>
+                <a:latin typeface="JetBrains Mono"/>
+              </a:rPr>
+              <a:t>) Admin API. </a:t>
+            </a:r>
+            <a:r>
+              <a:rPr lang="ko-KR" altLang="en-US" sz="1050" i="1">
+                <a:solidFill>
+                  <a:srgbClr val="5F826B"/>
+                </a:solidFill>
+                <a:latin typeface="Courier New" panose="02070309020205020404" pitchFamily="49" charset="0"/>
+              </a:rPr>
+              <a:t>필요 없으면 이 라인 제거 가능</a:t>
+            </a:r>
+            <a:br>
+              <a:rPr lang="ko-KR" altLang="en-US" sz="1050" i="1">
+                <a:solidFill>
+                  <a:srgbClr val="5F826B"/>
+                </a:solidFill>
+                <a:latin typeface="Courier New" panose="02070309020205020404" pitchFamily="49" charset="0"/>
+              </a:rPr>
+            </a:br>
+            <a:br>
+              <a:rPr lang="ko-KR" altLang="en-US" sz="1050" i="1">
+                <a:solidFill>
+                  <a:srgbClr val="5F826B"/>
+                </a:solidFill>
+                <a:latin typeface="Courier New" panose="02070309020205020404" pitchFamily="49" charset="0"/>
+              </a:rPr>
+            </a:br>
+            <a:r>
+              <a:rPr lang="ko-KR" altLang="en-US" sz="1050" i="1">
+                <a:solidFill>
+                  <a:srgbClr val="5F826B"/>
+                </a:solidFill>
+                <a:latin typeface="Courier New" panose="02070309020205020404" pitchFamily="49" charset="0"/>
+              </a:rPr>
+              <a:t>    </a:t>
+            </a:r>
+            <a:r>
+              <a:rPr lang="en-US" altLang="ko-KR" sz="1050" i="1">
+                <a:solidFill>
+                  <a:srgbClr val="5F826B"/>
+                </a:solidFill>
+                <a:latin typeface="JetBrains Mono"/>
+              </a:rPr>
+              <a:t># </a:t>
+            </a:r>
+            <a:r>
+              <a:rPr lang="ko-KR" altLang="en-US" sz="1050" i="1">
+                <a:solidFill>
+                  <a:srgbClr val="5F826B"/>
+                </a:solidFill>
+                <a:latin typeface="Courier New" panose="02070309020205020404" pitchFamily="49" charset="0"/>
+              </a:rPr>
+              <a:t>✅ 데이터 유지가 필요하면 볼륨 추가</a:t>
+            </a:r>
+            <a:br>
+              <a:rPr lang="ko-KR" altLang="en-US" sz="1050" i="1">
+                <a:solidFill>
+                  <a:srgbClr val="5F826B"/>
+                </a:solidFill>
+                <a:latin typeface="Courier New" panose="02070309020205020404" pitchFamily="49" charset="0"/>
+              </a:rPr>
+            </a:br>
+            <a:r>
+              <a:rPr lang="ko-KR" altLang="en-US" sz="1050" i="1">
+                <a:solidFill>
+                  <a:srgbClr val="5F826B"/>
+                </a:solidFill>
+                <a:latin typeface="Courier New" panose="02070309020205020404" pitchFamily="49" charset="0"/>
+              </a:rPr>
+              <a:t>    </a:t>
+            </a:r>
+            <a:r>
+              <a:rPr lang="en-US" altLang="ko-KR" sz="1050">
+                <a:solidFill>
+                  <a:srgbClr val="CF8E6D"/>
+                </a:solidFill>
+                <a:latin typeface="JetBrains Mono"/>
+              </a:rPr>
+              <a:t>volumes</a:t>
+            </a:r>
+            <a:r>
+              <a:rPr lang="en-US" altLang="ko-KR" sz="1050">
+                <a:solidFill>
+                  <a:srgbClr val="BCBEC4"/>
+                </a:solidFill>
+                <a:latin typeface="JetBrains Mono"/>
+              </a:rPr>
+              <a:t>:</a:t>
+            </a:r>
+            <a:br>
+              <a:rPr lang="en-US" altLang="ko-KR" sz="1050">
+                <a:solidFill>
+                  <a:srgbClr val="BCBEC4"/>
+                </a:solidFill>
+                <a:latin typeface="JetBrains Mono"/>
+              </a:rPr>
+            </a:br>
+            <a:r>
+              <a:rPr lang="en-US" altLang="ko-KR" sz="1050">
+                <a:solidFill>
+                  <a:srgbClr val="BCBEC4"/>
+                </a:solidFill>
+                <a:latin typeface="JetBrains Mono"/>
+              </a:rPr>
+              <a:t>      - redpanda_data:/var/lib/redpanda/data</a:t>
+            </a:r>
+            <a:endParaRPr lang="ko-KR" altLang="en-US" sz="1050"/>
+          </a:p>
+        </p:txBody>
+      </p:sp>
+      <p:grpSp>
+        <p:nvGrpSpPr>
+          <p:cNvPr id="2" name="그룹 1">
+            <a:extLst>
+              <a:ext uri="{FF2B5EF4-FFF2-40B4-BE49-F238E27FC236}">
+                <a16:creationId xmlns:a16="http://schemas.microsoft.com/office/drawing/2014/main" id="{BD64B968-E0D8-BE10-E2D0-0608A4C4B87C}"/>
+              </a:ext>
+            </a:extLst>
+          </p:cNvPr>
+          <p:cNvGrpSpPr/>
+          <p:nvPr/>
+        </p:nvGrpSpPr>
+        <p:grpSpPr>
+          <a:xfrm>
+            <a:off x="5955901" y="5432072"/>
+            <a:ext cx="1409897" cy="771633"/>
+            <a:chOff x="459876" y="2820673"/>
+            <a:chExt cx="1409897" cy="771633"/>
+          </a:xfrm>
+        </p:grpSpPr>
+        <p:pic>
+          <p:nvPicPr>
+            <p:cNvPr id="3" name="그림 2">
+              <a:extLst>
+                <a:ext uri="{FF2B5EF4-FFF2-40B4-BE49-F238E27FC236}">
+                  <a16:creationId xmlns:a16="http://schemas.microsoft.com/office/drawing/2014/main" id="{46B42ACF-A36F-CAA8-2920-8AEE7AD3B240}"/>
+                </a:ext>
+              </a:extLst>
+            </p:cNvPr>
+            <p:cNvPicPr>
+              <a:picLocks noChangeAspect="1"/>
+            </p:cNvPicPr>
+            <p:nvPr/>
+          </p:nvPicPr>
+          <p:blipFill>
+            <a:blip r:embed="rId2"/>
+            <a:stretch>
+              <a:fillRect/>
+            </a:stretch>
+          </p:blipFill>
+          <p:spPr>
+            <a:xfrm>
+              <a:off x="459876" y="2820673"/>
+              <a:ext cx="1409897" cy="771633"/>
+            </a:xfrm>
+            <a:prstGeom prst="rect">
+              <a:avLst/>
+            </a:prstGeom>
+          </p:spPr>
+        </p:pic>
+        <p:sp>
+          <p:nvSpPr>
+            <p:cNvPr id="4" name="직사각형 3">
+              <a:extLst>
+                <a:ext uri="{FF2B5EF4-FFF2-40B4-BE49-F238E27FC236}">
+                  <a16:creationId xmlns:a16="http://schemas.microsoft.com/office/drawing/2014/main" id="{A7A56861-086B-3B78-210A-B52F970691A0}"/>
+                </a:ext>
+              </a:extLst>
+            </p:cNvPr>
+            <p:cNvSpPr/>
+            <p:nvPr/>
+          </p:nvSpPr>
+          <p:spPr>
+            <a:xfrm>
+              <a:off x="741145" y="3282215"/>
+              <a:ext cx="1039529" cy="310091"/>
+            </a:xfrm>
+            <a:prstGeom prst="rect">
+              <a:avLst/>
+            </a:prstGeom>
+            <a:noFill/>
+            <a:ln>
+              <a:solidFill>
+                <a:srgbClr val="00B0F0"/>
+              </a:solidFill>
+            </a:ln>
+          </p:spPr>
+          <p:style>
+            <a:lnRef idx="2">
+              <a:schemeClr val="accent1">
+                <a:shade val="15000"/>
+              </a:schemeClr>
+            </a:lnRef>
+            <a:fillRef idx="1">
+              <a:schemeClr val="accent1"/>
+            </a:fillRef>
+            <a:effectRef idx="0">
+              <a:schemeClr val="accent1"/>
+            </a:effectRef>
+            <a:fontRef idx="minor">
+              <a:schemeClr val="lt1"/>
+            </a:fontRef>
+          </p:style>
+          <p:txBody>
+            <a:bodyPr rtlCol="0" anchor="ctr"/>
+            <a:lstStyle/>
+            <a:p>
+              <a:pPr algn="ctr"/>
+              <a:endParaRPr lang="ko-KR" altLang="en-US"/>
+            </a:p>
+          </p:txBody>
+        </p:sp>
+      </p:grpSp>
+      <p:sp>
+        <p:nvSpPr>
+          <p:cNvPr id="5" name="TextBox 4">
+            <a:extLst>
+              <a:ext uri="{FF2B5EF4-FFF2-40B4-BE49-F238E27FC236}">
+                <a16:creationId xmlns:a16="http://schemas.microsoft.com/office/drawing/2014/main" id="{9E1DA6FE-5BC6-49B7-BEB8-FDC99166A984}"/>
+              </a:ext>
+            </a:extLst>
+          </p:cNvPr>
+          <p:cNvSpPr txBox="1"/>
+          <p:nvPr/>
+        </p:nvSpPr>
+        <p:spPr>
+          <a:xfrm>
+            <a:off x="7365798" y="5431949"/>
+            <a:ext cx="2735711" cy="461665"/>
+          </a:xfrm>
+          <a:prstGeom prst="rect">
+            <a:avLst/>
+          </a:prstGeom>
+          <a:noFill/>
+        </p:spPr>
+        <p:txBody>
+          <a:bodyPr wrap="square" rtlCol="0">
+            <a:spAutoFit/>
+          </a:bodyPr>
+          <a:lstStyle/>
+          <a:p>
+            <a:r>
+              <a:rPr lang="en-US" altLang="ko-KR" sz="1200"/>
+              <a:t>compose.yml</a:t>
+            </a:r>
+            <a:r>
+              <a:rPr lang="ko-KR" altLang="en-US" sz="1200"/>
+              <a:t> 추가 </a:t>
+            </a:r>
+            <a:r>
+              <a:rPr lang="en-US" altLang="ko-KR" sz="1200"/>
+              <a:t>- </a:t>
+            </a:r>
+            <a:r>
+              <a:rPr lang="ko-KR" altLang="en-US" sz="1200"/>
+              <a:t>설정은 </a:t>
+            </a:r>
+            <a:r>
+              <a:rPr lang="en-US" altLang="ko-KR" sz="1200"/>
+              <a:t>git</a:t>
+            </a:r>
+            <a:r>
+              <a:rPr lang="ko-KR" altLang="en-US" sz="1200"/>
+              <a:t>에서 복제</a:t>
+            </a:r>
           </a:p>
         </p:txBody>
       </p:sp>
     </p:spTree>
     <p:extLst>
       <p:ext uri="{BB962C8B-B14F-4D97-AF65-F5344CB8AC3E}">
-        <p14:creationId xmlns:p14="http://schemas.microsoft.com/office/powerpoint/2010/main" val="1669074784"/>
+        <p14:creationId xmlns:p14="http://schemas.microsoft.com/office/powerpoint/2010/main" val="7535771"/>
+      </p:ext>
+    </p:extLst>
+  </p:cSld>
+  <p:clrMapOvr>
+    <a:masterClrMapping/>
+  </p:clrMapOvr>
+</p:sld>
+</file>
+
+<file path=ppt/slides/slide7.xml><?xml version="1.0" encoding="utf-8"?>
+<p:sld xmlns:a="http://schemas.openxmlformats.org/drawingml/2006/main" xmlns:r="http://schemas.openxmlformats.org/officeDocument/2006/relationships" xmlns:p="http://schemas.openxmlformats.org/presentationml/2006/main">
+  <p:cSld>
+    <p:spTree>
+      <p:nvGrpSpPr>
+        <p:cNvPr id="1" name=""/>
+        <p:cNvGrpSpPr/>
+        <p:nvPr/>
+      </p:nvGrpSpPr>
+      <p:grpSpPr>
+        <a:xfrm>
+          <a:off x="0" y="0"/>
+          <a:ext cx="0" cy="0"/>
+          <a:chOff x="0" y="0"/>
+          <a:chExt cx="0" cy="0"/>
+        </a:xfrm>
+      </p:grpSpPr>
+      <p:pic>
+        <p:nvPicPr>
+          <p:cNvPr id="11" name="그림 10">
+            <a:extLst>
+              <a:ext uri="{FF2B5EF4-FFF2-40B4-BE49-F238E27FC236}">
+                <a16:creationId xmlns:a16="http://schemas.microsoft.com/office/drawing/2014/main" id="{60DB1170-F50F-C621-21CF-FC2B9F3C50DE}"/>
+              </a:ext>
+            </a:extLst>
+          </p:cNvPr>
+          <p:cNvPicPr>
+            <a:picLocks noChangeAspect="1"/>
+          </p:cNvPicPr>
+          <p:nvPr/>
+        </p:nvPicPr>
+        <p:blipFill>
+          <a:blip r:embed="rId2"/>
+          <a:stretch>
+            <a:fillRect/>
+          </a:stretch>
+        </p:blipFill>
+        <p:spPr>
+          <a:xfrm>
+            <a:off x="9445602" y="4831882"/>
+            <a:ext cx="2664522" cy="1919466"/>
+          </a:xfrm>
+          <a:prstGeom prst="rect">
+            <a:avLst/>
+          </a:prstGeom>
+        </p:spPr>
+      </p:pic>
+      <p:sp>
+        <p:nvSpPr>
+          <p:cNvPr id="2" name="TextBox 1">
+            <a:extLst>
+              <a:ext uri="{FF2B5EF4-FFF2-40B4-BE49-F238E27FC236}">
+                <a16:creationId xmlns:a16="http://schemas.microsoft.com/office/drawing/2014/main" id="{49B6946F-5B35-3B02-259E-DA9176728C69}"/>
+              </a:ext>
+            </a:extLst>
+          </p:cNvPr>
+          <p:cNvSpPr txBox="1"/>
+          <p:nvPr/>
+        </p:nvSpPr>
+        <p:spPr>
+          <a:xfrm>
+            <a:off x="519764" y="452387"/>
+            <a:ext cx="11396312" cy="369332"/>
+          </a:xfrm>
+          <a:prstGeom prst="rect">
+            <a:avLst/>
+          </a:prstGeom>
+          <a:noFill/>
+        </p:spPr>
+        <p:txBody>
+          <a:bodyPr wrap="square" rtlCol="0">
+            <a:spAutoFit/>
+          </a:bodyPr>
+          <a:lstStyle/>
+          <a:p>
+            <a:r>
+              <a:rPr lang="en-US" altLang="ko-KR"/>
+              <a:t>IDE </a:t>
+            </a:r>
+            <a:r>
+              <a:rPr lang="ko-KR" altLang="en-US"/>
+              <a:t>환경에서 </a:t>
+            </a:r>
+            <a:r>
+              <a:rPr lang="en-US" altLang="ko-KR"/>
+              <a:t>compose </a:t>
+            </a:r>
+            <a:r>
+              <a:rPr lang="ko-KR" altLang="en-US"/>
+              <a:t>파일로 </a:t>
+            </a:r>
+            <a:r>
+              <a:rPr lang="en-US" altLang="ko-KR"/>
+              <a:t>Kafka </a:t>
+            </a:r>
+            <a:r>
+              <a:rPr lang="ko-KR" altLang="en-US"/>
+              <a:t>컨테이너 실행 </a:t>
+            </a:r>
+          </a:p>
+        </p:txBody>
+      </p:sp>
+      <p:grpSp>
+        <p:nvGrpSpPr>
+          <p:cNvPr id="6" name="그룹 5">
+            <a:extLst>
+              <a:ext uri="{FF2B5EF4-FFF2-40B4-BE49-F238E27FC236}">
+                <a16:creationId xmlns:a16="http://schemas.microsoft.com/office/drawing/2014/main" id="{E8F8CC47-34FA-9925-6A71-5E477C72B49C}"/>
+              </a:ext>
+            </a:extLst>
+          </p:cNvPr>
+          <p:cNvGrpSpPr/>
+          <p:nvPr/>
+        </p:nvGrpSpPr>
+        <p:grpSpPr>
+          <a:xfrm>
+            <a:off x="519764" y="972056"/>
+            <a:ext cx="2562583" cy="1371791"/>
+            <a:chOff x="519764" y="972056"/>
+            <a:chExt cx="2562583" cy="1371791"/>
+          </a:xfrm>
+        </p:grpSpPr>
+        <p:pic>
+          <p:nvPicPr>
+            <p:cNvPr id="4" name="그림 3">
+              <a:extLst>
+                <a:ext uri="{FF2B5EF4-FFF2-40B4-BE49-F238E27FC236}">
+                  <a16:creationId xmlns:a16="http://schemas.microsoft.com/office/drawing/2014/main" id="{D1060E04-BD3E-766E-E9D5-D87FEF91156F}"/>
+                </a:ext>
+              </a:extLst>
+            </p:cNvPr>
+            <p:cNvPicPr>
+              <a:picLocks noChangeAspect="1"/>
+            </p:cNvPicPr>
+            <p:nvPr/>
+          </p:nvPicPr>
+          <p:blipFill>
+            <a:blip r:embed="rId3"/>
+            <a:stretch>
+              <a:fillRect/>
+            </a:stretch>
+          </p:blipFill>
+          <p:spPr>
+            <a:xfrm>
+              <a:off x="519764" y="972056"/>
+              <a:ext cx="2562583" cy="1371791"/>
+            </a:xfrm>
+            <a:prstGeom prst="rect">
+              <a:avLst/>
+            </a:prstGeom>
+          </p:spPr>
+        </p:pic>
+        <p:sp>
+          <p:nvSpPr>
+            <p:cNvPr id="5" name="직사각형 4">
+              <a:extLst>
+                <a:ext uri="{FF2B5EF4-FFF2-40B4-BE49-F238E27FC236}">
+                  <a16:creationId xmlns:a16="http://schemas.microsoft.com/office/drawing/2014/main" id="{9A7C97B7-1180-56DD-9EC2-2D23F287B436}"/>
+                </a:ext>
+              </a:extLst>
+            </p:cNvPr>
+            <p:cNvSpPr/>
+            <p:nvPr/>
+          </p:nvSpPr>
+          <p:spPr>
+            <a:xfrm>
+              <a:off x="519764" y="1251284"/>
+              <a:ext cx="471638" cy="369332"/>
+            </a:xfrm>
+            <a:prstGeom prst="rect">
+              <a:avLst/>
+            </a:prstGeom>
+            <a:noFill/>
+            <a:ln>
+              <a:solidFill>
+                <a:srgbClr val="FF0000"/>
+              </a:solidFill>
+            </a:ln>
+          </p:spPr>
+          <p:style>
+            <a:lnRef idx="2">
+              <a:schemeClr val="accent1">
+                <a:shade val="15000"/>
+              </a:schemeClr>
+            </a:lnRef>
+            <a:fillRef idx="1">
+              <a:schemeClr val="accent1"/>
+            </a:fillRef>
+            <a:effectRef idx="0">
+              <a:schemeClr val="accent1"/>
+            </a:effectRef>
+            <a:fontRef idx="minor">
+              <a:schemeClr val="lt1"/>
+            </a:fontRef>
+          </p:style>
+          <p:txBody>
+            <a:bodyPr rtlCol="0" anchor="ctr"/>
+            <a:lstStyle/>
+            <a:p>
+              <a:pPr algn="ctr"/>
+              <a:endParaRPr lang="ko-KR" altLang="en-US"/>
+            </a:p>
+          </p:txBody>
+        </p:sp>
+      </p:grpSp>
+      <p:pic>
+        <p:nvPicPr>
+          <p:cNvPr id="8" name="그림 7">
+            <a:extLst>
+              <a:ext uri="{FF2B5EF4-FFF2-40B4-BE49-F238E27FC236}">
+                <a16:creationId xmlns:a16="http://schemas.microsoft.com/office/drawing/2014/main" id="{9AF041C1-D25D-F9A8-D04B-F3D202D102D8}"/>
+              </a:ext>
+            </a:extLst>
+          </p:cNvPr>
+          <p:cNvPicPr>
+            <a:picLocks noChangeAspect="1"/>
+          </p:cNvPicPr>
+          <p:nvPr/>
+        </p:nvPicPr>
+        <p:blipFill>
+          <a:blip r:embed="rId4"/>
+          <a:stretch>
+            <a:fillRect/>
+          </a:stretch>
+        </p:blipFill>
+        <p:spPr>
+          <a:xfrm>
+            <a:off x="3174181" y="972056"/>
+            <a:ext cx="6087478" cy="3969744"/>
+          </a:xfrm>
+          <a:prstGeom prst="rect">
+            <a:avLst/>
+          </a:prstGeom>
+        </p:spPr>
+      </p:pic>
+      <p:sp>
+        <p:nvSpPr>
+          <p:cNvPr id="9" name="TextBox 8">
+            <a:extLst>
+              <a:ext uri="{FF2B5EF4-FFF2-40B4-BE49-F238E27FC236}">
+                <a16:creationId xmlns:a16="http://schemas.microsoft.com/office/drawing/2014/main" id="{729A3FA1-A026-5687-0BC5-BD9444714852}"/>
+              </a:ext>
+            </a:extLst>
+          </p:cNvPr>
+          <p:cNvSpPr txBox="1"/>
+          <p:nvPr/>
+        </p:nvSpPr>
+        <p:spPr>
+          <a:xfrm>
+            <a:off x="3185962" y="5072514"/>
+            <a:ext cx="8807116" cy="461665"/>
+          </a:xfrm>
+          <a:prstGeom prst="rect">
+            <a:avLst/>
+          </a:prstGeom>
+          <a:noFill/>
+        </p:spPr>
+        <p:txBody>
+          <a:bodyPr wrap="square" rtlCol="0">
+            <a:spAutoFit/>
+          </a:bodyPr>
+          <a:lstStyle/>
+          <a:p>
+            <a:r>
+              <a:rPr lang="en-US" altLang="ko-KR" sz="1200"/>
+              <a:t>compose.yml</a:t>
+            </a:r>
+            <a:r>
+              <a:rPr lang="ko-KR" altLang="en-US" sz="1200"/>
+              <a:t> 에 보면 </a:t>
+            </a:r>
+            <a:r>
+              <a:rPr lang="en-US" altLang="ko-KR" sz="1200"/>
+              <a:t>console</a:t>
+            </a:r>
+            <a:r>
+              <a:rPr lang="ko-KR" altLang="en-US" sz="1200"/>
+              <a:t>이라는 컨테이너가 보인다</a:t>
+            </a:r>
+            <a:r>
+              <a:rPr lang="en-US" altLang="ko-KR" sz="1200"/>
+              <a:t>.</a:t>
+            </a:r>
+            <a:br>
+              <a:rPr lang="en-US" altLang="ko-KR" sz="1200"/>
+            </a:br>
+            <a:r>
+              <a:rPr lang="ko-KR" altLang="en-US" sz="1200"/>
+              <a:t>이는 카프카 상황을 모니터링하기 쉽게해주는 </a:t>
+            </a:r>
+            <a:r>
+              <a:rPr lang="en-US" altLang="ko-KR" sz="1200"/>
+              <a:t>RedPanda</a:t>
+            </a:r>
+            <a:r>
+              <a:rPr lang="ko-KR" altLang="en-US" sz="1200"/>
+              <a:t>가 제공하는</a:t>
+            </a:r>
+            <a:r>
+              <a:rPr lang="en-US" altLang="ko-KR" sz="1200"/>
+              <a:t> </a:t>
+            </a:r>
+            <a:r>
+              <a:rPr lang="ko-KR" altLang="en-US" sz="1200"/>
+              <a:t>유틸리티 사이트이다</a:t>
+            </a:r>
+            <a:r>
+              <a:rPr lang="en-US" altLang="ko-KR" sz="1200"/>
+              <a:t>.</a:t>
+            </a:r>
+            <a:endParaRPr lang="ko-KR" altLang="en-US" sz="1200"/>
+          </a:p>
+        </p:txBody>
+      </p:sp>
+    </p:spTree>
+    <p:extLst>
+      <p:ext uri="{BB962C8B-B14F-4D97-AF65-F5344CB8AC3E}">
+        <p14:creationId xmlns:p14="http://schemas.microsoft.com/office/powerpoint/2010/main" val="91632835"/>
+      </p:ext>
+    </p:extLst>
+  </p:cSld>
+  <p:clrMapOvr>
+    <a:masterClrMapping/>
+  </p:clrMapOvr>
+</p:sld>
+</file>
+
+<file path=ppt/slides/slide8.xml><?xml version="1.0" encoding="utf-8"?>
+<p:sld xmlns:a="http://schemas.openxmlformats.org/drawingml/2006/main" xmlns:r="http://schemas.openxmlformats.org/officeDocument/2006/relationships" xmlns:p="http://schemas.openxmlformats.org/presentationml/2006/main">
+  <p:cSld>
+    <p:spTree>
+      <p:nvGrpSpPr>
+        <p:cNvPr id="1" name=""/>
+        <p:cNvGrpSpPr/>
+        <p:nvPr/>
+      </p:nvGrpSpPr>
+      <p:grpSpPr>
+        <a:xfrm>
+          <a:off x="0" y="0"/>
+          <a:ext cx="0" cy="0"/>
+          <a:chOff x="0" y="0"/>
+          <a:chExt cx="0" cy="0"/>
+        </a:xfrm>
+      </p:grpSpPr>
+    </p:spTree>
+    <p:extLst>
+      <p:ext uri="{BB962C8B-B14F-4D97-AF65-F5344CB8AC3E}">
+        <p14:creationId xmlns:p14="http://schemas.microsoft.com/office/powerpoint/2010/main" val="3661453845"/>
       </p:ext>
     </p:extLst>
   </p:cSld>

</xml_diff>